<commit_message>
Pitch: corrections du jury (sécurité, coût, boucle pilote, IA, score, preuves), pptx régénéré
</commit_message>
<xml_diff>
--- a/docs/pitch/Maillage.pptx
+++ b/docs/pitch/Maillage.pptx
@@ -659,12 +659,12 @@
           <a:lstStyle/>
           <a:p>
             <a:r>
-              <a:t>Visuel : capture de l’écran de proposition.</a:t>
-            </a:r>
-          </a:p>
-          <a:p>
-            <a:r>
-              <a:t>Signal [CIAN] : « Voici Maillage », puis passer au téléphone pour la démo. (1 min 40 s avec la démo)</a:t>
+              <a:t>Visuel : capture de l’écran de proposition. Message de fond : une app mobile qui propose des projets à trois partenaires, sur la carte, avec les raisons.</a:t>
+            </a:r>
+          </a:p>
+          <a:p>
+            <a:r>
+              <a:t>Signal [CIAN] : « Voici Maillage », puis passer au téléphone pour la démo. (1 min 45 s avec la démo)</a:t>
             </a:r>
           </a:p>
         </p:txBody>
@@ -829,7 +829,7 @@
           </a:p>
           <a:p>
             <a:r>
-              <a:t>Signal [CIAN] : trois idées seulement : profils cachés tant que non réclamés, fichiers confidentiels non publiés, structure prête pour la Ville. (40 s)</a:t>
+              <a:t>Signal [CIAN] : trois idées seulement : profils cachés tant que non réclamés, fichiers confidentiels non publiés, structure prête pour la Ville. Dire : « Nos profils et nos règles s’appuient sur les colonnes des répertoires de la Ville et sur le Plan d’action Saint-Roch. » (35 s)</a:t>
             </a:r>
           </a:p>
         </p:txBody>
@@ -899,12 +899,12 @@
           <a:lstStyle/>
           <a:p>
             <a:r>
-              <a:t>Visuel : une carte de proposition avec « Pourquoi cette suggestion » et « À confirmer » surlignés; en bas, le test d’IA : « Modèle multilingue dans le navigateur, gratuit, texte sur l’appareil (page /labo/) : 69 s au premier chargement (129 Mo), 13 s ensuite, 0,3 à 0,6 s par phrase. Trouve des profils semblables, pas complémentaires. » À droite : « Phase 2 : l’IA lit la demande libre ».</a:t>
-            </a:r>
-          </a:p>
-          <a:p>
-            <a:r>
-              <a:t>Signal [COÉQUIPIÈRE] : où est l’IA? Nous l’avons testée; elle trouve du semblable, pas du complémentaire, d’où le moteur de règles. Phase 2 : lire la demande libre. Le coût revient à celui qui déploie. (55 s)</a:t>
+              <a:t>Visuel : une carte de proposition avec « Pourquoi cette suggestion » et « À confirmer » surlignés; en bas, en petit : « Chaque suggestion s’explique, sans boîte noire. » Notes du test d’IA (pas sur la diapo, à voix haute seulement si on veut) : « Modèle multilingue dans le navigateur, gratuit, texte sur l’appareil (page /labo/) : 69 s au premier chargement (129 Mo), 13 s ensuite, 0,3 à 0,6 s par phrase. Trouve des profils semblables, pas complémentaires. »</a:t>
+            </a:r>
+          </a:p>
+          <a:p>
+            <a:r>
+              <a:t>Signal [COÉQUIPIÈRE] : verdict d’abord : on l’a testé, on a choisi des règles pour que chaque suggestion s’explique. Chiffres du test seulement si le jury demande. (45 s)</a:t>
             </a:r>
           </a:p>
         </p:txBody>
@@ -999,7 +999,7 @@
           </a:p>
           <a:p>
             <a:r>
-              <a:t>Signal [CIAN] : « Voici comment on le ferait pour de vrai. » (40 s)</a:t>
+              <a:t>Signal [CIAN] : coût : « Hébergement gratuit pour un projet pilote, et une personne à temps partiel à la SDC pour l’accueil et la modération. » Dans la démo aucun message ne part; en pilote, la boucle complète est ce qu’on ajoute. (40 s)</a:t>
             </a:r>
           </a:p>
         </p:txBody>
@@ -4719,7 +4719,7 @@
                 </a:solidFill>
                 <a:latin typeface="Calibri"/>
               </a:rPr>
-              <a:t>Une app mobile qui propose des projets à trois partenaires, sur la carte, avec les raisons.</a:t>
+              <a:t>Les autres apps informent; Maillage fait collaborer : trois partenaires complémentaires, un projet concret.</a:t>
             </a:r>
           </a:p>
         </p:txBody>
@@ -6465,7 +6465,7 @@
                 </a:solidFill>
                 <a:latin typeface="Calibri"/>
               </a:rPr>
-              <a:t>Chaque suggestion explique pourquoi. L’app suggère, les personnes décident.</a:t>
+              <a:t>On l’a testé, on a choisi des règles pour que chaque suggestion s’explique.</a:t>
             </a:r>
           </a:p>
         </p:txBody>
@@ -6588,7 +6588,7 @@
                 </a:solidFill>
                 <a:latin typeface="Calibri"/>
               </a:rPr>
-              <a:t>Règles : chaque raison est visible</a:t>
+              <a:t>Règles visibles</a:t>
             </a:r>
           </a:p>
         </p:txBody>
@@ -6711,7 +6711,7 @@
                 </a:solidFill>
                 <a:latin typeface="Calibri"/>
               </a:rPr>
-              <a:t>Test d’IA : semblable, pas complémentaire</a:t>
+              <a:t>Score pondéré visible</a:t>
             </a:r>
           </a:p>
         </p:txBody>
@@ -6834,7 +6834,7 @@
                 </a:solidFill>
                 <a:latin typeface="Calibri"/>
               </a:rPr>
-              <a:t>Phase 2 : l’IA lit la demande</a:t>
+              <a:t>Phase 2 : l’IA lit la demande libre</a:t>
             </a:r>
           </a:p>
         </p:txBody>
@@ -7211,7 +7211,7 @@
                 </a:solidFill>
                 <a:latin typeface="Calibri"/>
               </a:rPr>
-              <a:t>Maintenant : démo avec données fictives</a:t>
+              <a:t>Maintenant : démo simulée</a:t>
             </a:r>
           </a:p>
         </p:txBody>
@@ -7334,7 +7334,7 @@
                 </a:solidFill>
                 <a:latin typeface="Calibri"/>
               </a:rPr>
-              <a:t>Ensuite : pilote avec la SDC</a:t>
+              <a:t>Pilote : chaque partenaire reçoit l’invitation et accepte</a:t>
             </a:r>
           </a:p>
         </p:txBody>
@@ -7457,7 +7457,7 @@
                 </a:solidFill>
                 <a:latin typeface="Calibri"/>
               </a:rPr>
-              <a:t>Plus tard : IA et autres quartiers</a:t>
+              <a:t>Plus tard : IA, autres quartiers</a:t>
             </a:r>
           </a:p>
         </p:txBody>

</xml_diff>

<commit_message>
Pitch: positionnement positif, nombres des répertoires, validation locale, portée, gouvernance, couleurs
</commit_message>
<xml_diff>
--- a/docs/pitch/Maillage.pptx
+++ b/docs/pitch/Maillage.pptx
@@ -659,7 +659,7 @@
           <a:lstStyle/>
           <a:p>
             <a:r>
-              <a:t>Visuel : capture de l’écran de proposition. Message de fond : une app mobile qui propose des projets à trois partenaires, sur la carte, avec les raisons.</a:t>
+              <a:t>Visuel : capture de l’écran de proposition. Couleurs (notes) : le vert profond rassure et ancre l’app dans le quartier, l’orange invite à agir; chaque couleur respecte les contrastes d’accessibilité et les épingles combinent forme, icône et couleur pour les personnes daltoniennes (environ 8 % des hommes). Phrase complète à dire : « Maillage ne remplace aucun outil existant : il crée le lien qui manque entre ceux qui ont des ressources et ceux qui ont des projets. » Message de fond : une app mobile qui propose des projets à trois partenaires, sur la carte, avec les raisons.</a:t>
             </a:r>
           </a:p>
           <a:p>
@@ -829,7 +829,7 @@
           </a:p>
           <a:p>
             <a:r>
-              <a:t>Signal [CIAN] : trois idées seulement : profils cachés tant que non réclamés, fichiers confidentiels non publiés, structure prête pour la Ville. Dire : « Nos profils et nos règles s’appuient sur les colonnes des répertoires de la Ville et sur le Plan d’action Saint-Roch. » (35 s)</a:t>
+              <a:t>Signal [CIAN] : trois idées seulement : profils cachés tant que non réclamés, fichiers confidentiels non publiés, structure prête pour la Ville. Dire : « La Ville et ses partenaires recensent déjà 614 organismes reconnus, 337 organismes soutenus, 487 entreprises dans Saint-Roch, 386 membres de la SDC, 1 960 installations et 379 événements à venir. Maillage part de ces répertoires : personne ne commence avec une page blanche. » Nos règles s’appuient aussi sur le Plan d’action Saint-Roch. (35 s)</a:t>
             </a:r>
           </a:p>
         </p:txBody>
@@ -899,12 +899,12 @@
           <a:lstStyle/>
           <a:p>
             <a:r>
-              <a:t>Visuel : une carte de proposition avec « Pourquoi cette suggestion » et « À confirmer » surlignés; en bas, en petit : « Chaque suggestion s’explique, sans boîte noire. » Notes du test d’IA (pas sur la diapo, à voix haute seulement si on veut) : « Modèle multilingue dans le navigateur, gratuit, texte sur l’appareil (page /labo/) : 69 s au premier chargement (129 Mo), 13 s ensuite, 0,3 à 0,6 s par phrase. Trouve des profils semblables, pas complémentaires. »</a:t>
-            </a:r>
-          </a:p>
-          <a:p>
-            <a:r>
-              <a:t>Signal [COÉQUIPIÈRE] : verdict d’abord : on l’a testé, on a choisi des règles pour que chaque suggestion s’explique. Chiffres du test seulement si le jury demande. (45 s)</a:t>
+              <a:t>Visuel : une carte de proposition avec « Pourquoi cette suggestion » et « À confirmer » surlignés; en bas, en petit : « Chaque suggestion s’explique. » Notes du test d’IA (pas sur la diapo, à voix haute seulement si on veut) : « Modèle multilingue dans le navigateur, gratuit, texte sur l’appareil (page /labo/) : 69 s au premier chargement (129 Mo), 13 s ensuite, 0,3 à 0,6 s par phrase. Trouve des profils semblables, pas complémentaires. »</a:t>
+            </a:r>
+          </a:p>
+          <a:p>
+            <a:r>
+              <a:t>Signal [COÉQUIPIÈRE] : verdict d’abord : on l’a testé, on a choisi des règles pour que chaque suggestion s’explique. Chiffres du test seulement si le jury demande. (35 s)</a:t>
             </a:r>
           </a:p>
         </p:txBody>
@@ -999,7 +999,12 @@
           </a:p>
           <a:p>
             <a:r>
-              <a:t>Signal [CIAN] : coût : « Hébergement gratuit pour un projet pilote, et une personne à temps partiel à la SDC pour l’accueil et la modération. » Dans la démo aucun message ne part; en pilote, la boucle complète est ce qu’on ajoute. (40 s)</a:t>
+              <a:t>Signal [CIAN] : portée : « Maillage règle un problème précis, de bout en bout : trouver le bon partenaire, se mettre d’accord, se coordonner et passer à l’action. On s’arrête là où d’autres outils existent (311, 911, plateformes de financement). » Puis coût : « Hébergement gratuit pour un projet pilote, et une personne à temps partiel à la SDC pour l’accueil et la modération. » Dans la démo aucun message ne part; en pilote, la boucle complète est ce qu’on ajoute. (50 s)</a:t>
+            </a:r>
+          </a:p>
+          <a:p>
+            <a:r>
+              <a:t>À ajouter à la feuille de route seulement si non démontré en direct : Explorer le quartier, profils publics, fil de projet, projets ouverts.</a:t>
             </a:r>
           </a:p>
         </p:txBody>
@@ -4465,14 +4470,383 @@
                 </a:solidFill>
                 <a:latin typeface="Calibri"/>
               </a:rPr>
-              <a:t>Les ressources de Saint-Roch sont là, mais les voisins ne se connaissent pas.</a:t>
-            </a:r>
-          </a:p>
-        </p:txBody>
-      </p:sp>
-      <p:sp>
-        <p:nvSpPr>
-          <p:cNvPr id="6" name="TextBox 5"/>
+              <a:t>Les initiatives existent. Ce qui manque, c’est le réseau qui les relie.</a:t>
+            </a:r>
+          </a:p>
+        </p:txBody>
+      </p:sp>
+      <p:sp>
+        <p:nvSpPr>
+          <p:cNvPr id="6" name="Rounded Rectangle 5"/>
+          <p:cNvSpPr/>
+          <p:nvPr/>
+        </p:nvSpPr>
+        <p:spPr>
+          <a:xfrm>
+            <a:off x="640080" y="3337560"/>
+            <a:ext cx="3484778" cy="2377440"/>
+          </a:xfrm>
+          <a:prstGeom prst="roundRect">
+            <a:avLst/>
+          </a:prstGeom>
+          <a:solidFill>
+            <a:srgbClr val="FFFFFF"/>
+          </a:solidFill>
+          <a:ln>
+            <a:noFill/>
+          </a:ln>
+          <a:effectLst/>
+        </p:spPr>
+        <p:style>
+          <a:lnRef idx="1">
+            <a:schemeClr val="accent1"/>
+          </a:lnRef>
+          <a:fillRef idx="3">
+            <a:schemeClr val="accent1"/>
+          </a:fillRef>
+          <a:effectRef idx="2">
+            <a:schemeClr val="accent1"/>
+          </a:effectRef>
+          <a:fontRef idx="minor">
+            <a:schemeClr val="lt1"/>
+          </a:fontRef>
+        </p:style>
+        <p:txBody>
+          <a:bodyPr rtlCol="0" anchor="ctr"/>
+          <a:lstStyle/>
+          <a:p>
+            <a:pPr algn="ctr"/>
+          </a:p>
+        </p:txBody>
+      </p:sp>
+      <p:sp>
+        <p:nvSpPr>
+          <p:cNvPr id="7" name="Rectangle 6"/>
+          <p:cNvSpPr/>
+          <p:nvPr/>
+        </p:nvSpPr>
+        <p:spPr>
+          <a:xfrm>
+            <a:off x="640080" y="3337560"/>
+            <a:ext cx="3484778" cy="109728"/>
+          </a:xfrm>
+          <a:prstGeom prst="rect">
+            <a:avLst/>
+          </a:prstGeom>
+          <a:solidFill>
+            <a:srgbClr val="E8833A"/>
+          </a:solidFill>
+          <a:ln>
+            <a:noFill/>
+          </a:ln>
+          <a:effectLst/>
+        </p:spPr>
+        <p:style>
+          <a:lnRef idx="1">
+            <a:schemeClr val="accent1"/>
+          </a:lnRef>
+          <a:fillRef idx="3">
+            <a:schemeClr val="accent1"/>
+          </a:fillRef>
+          <a:effectRef idx="2">
+            <a:schemeClr val="accent1"/>
+          </a:effectRef>
+          <a:fontRef idx="minor">
+            <a:schemeClr val="lt1"/>
+          </a:fontRef>
+        </p:style>
+        <p:txBody>
+          <a:bodyPr rtlCol="0" anchor="ctr"/>
+          <a:lstStyle/>
+          <a:p>
+            <a:pPr algn="ctr"/>
+          </a:p>
+        </p:txBody>
+      </p:sp>
+      <p:sp>
+        <p:nvSpPr>
+          <p:cNvPr id="8" name="TextBox 7"/>
+          <p:cNvSpPr txBox="1"/>
+          <p:nvPr/>
+        </p:nvSpPr>
+        <p:spPr>
+          <a:xfrm>
+            <a:off x="822960" y="3566160"/>
+            <a:ext cx="3119018" cy="2011680"/>
+          </a:xfrm>
+          <a:prstGeom prst="rect">
+            <a:avLst/>
+          </a:prstGeom>
+          <a:noFill/>
+        </p:spPr>
+        <p:txBody>
+          <a:bodyPr wrap="square" anchor="ctr">
+            <a:spAutoFit/>
+          </a:bodyPr>
+          <a:lstStyle/>
+          <a:p>
+            <a:pPr algn="l"/>
+            <a:r>
+              <a:rPr sz="2400" b="0">
+                <a:solidFill>
+                  <a:srgbClr val="222B27"/>
+                </a:solidFill>
+                <a:latin typeface="Calibri"/>
+              </a:rPr>
+              <a:t>Un café</a:t>
+            </a:r>
+          </a:p>
+        </p:txBody>
+      </p:sp>
+      <p:sp>
+        <p:nvSpPr>
+          <p:cNvPr id="9" name="Rounded Rectangle 8"/>
+          <p:cNvSpPr/>
+          <p:nvPr/>
+        </p:nvSpPr>
+        <p:spPr>
+          <a:xfrm>
+            <a:off x="4353458" y="3337560"/>
+            <a:ext cx="3484778" cy="2377440"/>
+          </a:xfrm>
+          <a:prstGeom prst="roundRect">
+            <a:avLst/>
+          </a:prstGeom>
+          <a:solidFill>
+            <a:srgbClr val="FFFFFF"/>
+          </a:solidFill>
+          <a:ln>
+            <a:noFill/>
+          </a:ln>
+          <a:effectLst/>
+        </p:spPr>
+        <p:style>
+          <a:lnRef idx="1">
+            <a:schemeClr val="accent1"/>
+          </a:lnRef>
+          <a:fillRef idx="3">
+            <a:schemeClr val="accent1"/>
+          </a:fillRef>
+          <a:effectRef idx="2">
+            <a:schemeClr val="accent1"/>
+          </a:effectRef>
+          <a:fontRef idx="minor">
+            <a:schemeClr val="lt1"/>
+          </a:fontRef>
+        </p:style>
+        <p:txBody>
+          <a:bodyPr rtlCol="0" anchor="ctr"/>
+          <a:lstStyle/>
+          <a:p>
+            <a:pPr algn="ctr"/>
+          </a:p>
+        </p:txBody>
+      </p:sp>
+      <p:sp>
+        <p:nvSpPr>
+          <p:cNvPr id="10" name="Rectangle 9"/>
+          <p:cNvSpPr/>
+          <p:nvPr/>
+        </p:nvSpPr>
+        <p:spPr>
+          <a:xfrm>
+            <a:off x="4353458" y="3337560"/>
+            <a:ext cx="3484778" cy="109728"/>
+          </a:xfrm>
+          <a:prstGeom prst="rect">
+            <a:avLst/>
+          </a:prstGeom>
+          <a:solidFill>
+            <a:srgbClr val="E8833A"/>
+          </a:solidFill>
+          <a:ln>
+            <a:noFill/>
+          </a:ln>
+          <a:effectLst/>
+        </p:spPr>
+        <p:style>
+          <a:lnRef idx="1">
+            <a:schemeClr val="accent1"/>
+          </a:lnRef>
+          <a:fillRef idx="3">
+            <a:schemeClr val="accent1"/>
+          </a:fillRef>
+          <a:effectRef idx="2">
+            <a:schemeClr val="accent1"/>
+          </a:effectRef>
+          <a:fontRef idx="minor">
+            <a:schemeClr val="lt1"/>
+          </a:fontRef>
+        </p:style>
+        <p:txBody>
+          <a:bodyPr rtlCol="0" anchor="ctr"/>
+          <a:lstStyle/>
+          <a:p>
+            <a:pPr algn="ctr"/>
+          </a:p>
+        </p:txBody>
+      </p:sp>
+      <p:sp>
+        <p:nvSpPr>
+          <p:cNvPr id="11" name="TextBox 10"/>
+          <p:cNvSpPr txBox="1"/>
+          <p:nvPr/>
+        </p:nvSpPr>
+        <p:spPr>
+          <a:xfrm>
+            <a:off x="4536338" y="3566160"/>
+            <a:ext cx="3119018" cy="2011680"/>
+          </a:xfrm>
+          <a:prstGeom prst="rect">
+            <a:avLst/>
+          </a:prstGeom>
+          <a:noFill/>
+        </p:spPr>
+        <p:txBody>
+          <a:bodyPr wrap="square" anchor="ctr">
+            <a:spAutoFit/>
+          </a:bodyPr>
+          <a:lstStyle/>
+          <a:p>
+            <a:pPr algn="l"/>
+            <a:r>
+              <a:rPr sz="2400" b="0">
+                <a:solidFill>
+                  <a:srgbClr val="222B27"/>
+                </a:solidFill>
+                <a:latin typeface="Calibri"/>
+              </a:rPr>
+              <a:t>Une artiste</a:t>
+            </a:r>
+          </a:p>
+        </p:txBody>
+      </p:sp>
+      <p:sp>
+        <p:nvSpPr>
+          <p:cNvPr id="12" name="Rounded Rectangle 11"/>
+          <p:cNvSpPr/>
+          <p:nvPr/>
+        </p:nvSpPr>
+        <p:spPr>
+          <a:xfrm>
+            <a:off x="8066836" y="3337560"/>
+            <a:ext cx="3484778" cy="2377440"/>
+          </a:xfrm>
+          <a:prstGeom prst="roundRect">
+            <a:avLst/>
+          </a:prstGeom>
+          <a:solidFill>
+            <a:srgbClr val="FFFFFF"/>
+          </a:solidFill>
+          <a:ln>
+            <a:noFill/>
+          </a:ln>
+          <a:effectLst/>
+        </p:spPr>
+        <p:style>
+          <a:lnRef idx="1">
+            <a:schemeClr val="accent1"/>
+          </a:lnRef>
+          <a:fillRef idx="3">
+            <a:schemeClr val="accent1"/>
+          </a:fillRef>
+          <a:effectRef idx="2">
+            <a:schemeClr val="accent1"/>
+          </a:effectRef>
+          <a:fontRef idx="minor">
+            <a:schemeClr val="lt1"/>
+          </a:fontRef>
+        </p:style>
+        <p:txBody>
+          <a:bodyPr rtlCol="0" anchor="ctr"/>
+          <a:lstStyle/>
+          <a:p>
+            <a:pPr algn="ctr"/>
+          </a:p>
+        </p:txBody>
+      </p:sp>
+      <p:sp>
+        <p:nvSpPr>
+          <p:cNvPr id="13" name="Rectangle 12"/>
+          <p:cNvSpPr/>
+          <p:nvPr/>
+        </p:nvSpPr>
+        <p:spPr>
+          <a:xfrm>
+            <a:off x="8066836" y="3337560"/>
+            <a:ext cx="3484778" cy="109728"/>
+          </a:xfrm>
+          <a:prstGeom prst="rect">
+            <a:avLst/>
+          </a:prstGeom>
+          <a:solidFill>
+            <a:srgbClr val="E8833A"/>
+          </a:solidFill>
+          <a:ln>
+            <a:noFill/>
+          </a:ln>
+          <a:effectLst/>
+        </p:spPr>
+        <p:style>
+          <a:lnRef idx="1">
+            <a:schemeClr val="accent1"/>
+          </a:lnRef>
+          <a:fillRef idx="3">
+            <a:schemeClr val="accent1"/>
+          </a:fillRef>
+          <a:effectRef idx="2">
+            <a:schemeClr val="accent1"/>
+          </a:effectRef>
+          <a:fontRef idx="minor">
+            <a:schemeClr val="lt1"/>
+          </a:fontRef>
+        </p:style>
+        <p:txBody>
+          <a:bodyPr rtlCol="0" anchor="ctr"/>
+          <a:lstStyle/>
+          <a:p>
+            <a:pPr algn="ctr"/>
+          </a:p>
+        </p:txBody>
+      </p:sp>
+      <p:sp>
+        <p:nvSpPr>
+          <p:cNvPr id="14" name="TextBox 13"/>
+          <p:cNvSpPr txBox="1"/>
+          <p:nvPr/>
+        </p:nvSpPr>
+        <p:spPr>
+          <a:xfrm>
+            <a:off x="8249716" y="3566160"/>
+            <a:ext cx="3119018" cy="2011680"/>
+          </a:xfrm>
+          <a:prstGeom prst="rect">
+            <a:avLst/>
+          </a:prstGeom>
+          <a:noFill/>
+        </p:spPr>
+        <p:txBody>
+          <a:bodyPr wrap="square" anchor="ctr">
+            <a:spAutoFit/>
+          </a:bodyPr>
+          <a:lstStyle/>
+          <a:p>
+            <a:pPr algn="l"/>
+            <a:r>
+              <a:rPr sz="2400" b="0">
+                <a:solidFill>
+                  <a:srgbClr val="222B27"/>
+                </a:solidFill>
+                <a:latin typeface="Calibri"/>
+              </a:rPr>
+              <a:t>Un organisme</a:t>
+            </a:r>
+          </a:p>
+        </p:txBody>
+      </p:sp>
+      <p:sp>
+        <p:nvSpPr>
+          <p:cNvPr id="15" name="TextBox 14"/>
           <p:cNvSpPr txBox="1"/>
           <p:nvPr/>
         </p:nvSpPr>
@@ -4507,7 +4881,7 @@
       </p:sp>
       <p:sp>
         <p:nvSpPr>
-          <p:cNvPr id="7" name="TextBox 6"/>
+          <p:cNvPr id="16" name="TextBox 15"/>
           <p:cNvSpPr txBox="1"/>
           <p:nvPr/>
         </p:nvSpPr>
@@ -4719,7 +5093,7 @@
                 </a:solidFill>
                 <a:latin typeface="Calibri"/>
               </a:rPr>
-              <a:t>Les autres apps informent; Maillage fait collaborer : trois partenaires complémentaires, un projet concret.</a:t>
+              <a:t>Maillage ne remplace aucun outil existant : il crée le lien qui manque.</a:t>
             </a:r>
           </a:p>
         </p:txBody>
@@ -5842,7 +6216,7 @@
                 </a:solidFill>
                 <a:latin typeface="Calibri"/>
               </a:rPr>
-              <a:t>Une app web légère, des données ouvertes, des profils protégés.</a:t>
+              <a:t>Personne ne commence avec une page blanche.</a:t>
             </a:r>
           </a:p>
         </p:txBody>
@@ -5856,7 +6230,7 @@
         <p:spPr>
           <a:xfrm>
             <a:off x="640080" y="3337560"/>
-            <a:ext cx="3484778" cy="2377440"/>
+            <a:ext cx="2556433" cy="2377440"/>
           </a:xfrm>
           <a:prstGeom prst="roundRect">
             <a:avLst/>
@@ -5900,7 +6274,7 @@
         <p:spPr>
           <a:xfrm>
             <a:off x="640080" y="3337560"/>
-            <a:ext cx="3484778" cy="109728"/>
+            <a:ext cx="2556433" cy="109728"/>
           </a:xfrm>
           <a:prstGeom prst="rect">
             <a:avLst/>
@@ -5944,7 +6318,7 @@
         <p:spPr>
           <a:xfrm>
             <a:off x="822960" y="3566160"/>
-            <a:ext cx="3119018" cy="2011680"/>
+            <a:ext cx="2190673" cy="2011680"/>
           </a:xfrm>
           <a:prstGeom prst="rect">
             <a:avLst/>
@@ -5959,7 +6333,7 @@
           <a:p>
             <a:pPr algn="l"/>
             <a:r>
-              <a:rPr sz="2400" b="0">
+              <a:rPr sz="2000" b="0">
                 <a:solidFill>
                   <a:srgbClr val="222B27"/>
                 </a:solidFill>
@@ -5978,8 +6352,8 @@
         </p:nvSpPr>
         <p:spPr>
           <a:xfrm>
-            <a:off x="4353458" y="3337560"/>
-            <a:ext cx="3484778" cy="2377440"/>
+            <a:off x="3425113" y="3337560"/>
+            <a:ext cx="2556433" cy="2377440"/>
           </a:xfrm>
           <a:prstGeom prst="roundRect">
             <a:avLst/>
@@ -6022,8 +6396,8 @@
         </p:nvSpPr>
         <p:spPr>
           <a:xfrm>
-            <a:off x="4353458" y="3337560"/>
-            <a:ext cx="3484778" cy="109728"/>
+            <a:off x="3425113" y="3337560"/>
+            <a:ext cx="2556433" cy="109728"/>
           </a:xfrm>
           <a:prstGeom prst="rect">
             <a:avLst/>
@@ -6066,8 +6440,8 @@
         </p:nvSpPr>
         <p:spPr>
           <a:xfrm>
-            <a:off x="4536338" y="3566160"/>
-            <a:ext cx="3119018" cy="2011680"/>
+            <a:off x="3607993" y="3566160"/>
+            <a:ext cx="2190673" cy="2011680"/>
           </a:xfrm>
           <a:prstGeom prst="rect">
             <a:avLst/>
@@ -6082,7 +6456,7 @@
           <a:p>
             <a:pPr algn="l"/>
             <a:r>
-              <a:rPr sz="2400" b="0">
+              <a:rPr sz="2000" b="0">
                 <a:solidFill>
                   <a:srgbClr val="222B27"/>
                 </a:solidFill>
@@ -6101,8 +6475,8 @@
         </p:nvSpPr>
         <p:spPr>
           <a:xfrm>
-            <a:off x="8066836" y="3337560"/>
-            <a:ext cx="3484778" cy="2377440"/>
+            <a:off x="6210146" y="3337560"/>
+            <a:ext cx="2556433" cy="2377440"/>
           </a:xfrm>
           <a:prstGeom prst="roundRect">
             <a:avLst/>
@@ -6145,8 +6519,8 @@
         </p:nvSpPr>
         <p:spPr>
           <a:xfrm>
-            <a:off x="8066836" y="3337560"/>
-            <a:ext cx="3484778" cy="109728"/>
+            <a:off x="6210146" y="3337560"/>
+            <a:ext cx="2556433" cy="109728"/>
           </a:xfrm>
           <a:prstGeom prst="rect">
             <a:avLst/>
@@ -6189,8 +6563,8 @@
         </p:nvSpPr>
         <p:spPr>
           <a:xfrm>
-            <a:off x="8249716" y="3566160"/>
-            <a:ext cx="3119018" cy="2011680"/>
+            <a:off x="6393026" y="3566160"/>
+            <a:ext cx="2190673" cy="2011680"/>
           </a:xfrm>
           <a:prstGeom prst="rect">
             <a:avLst/>
@@ -6205,20 +6579,143 @@
           <a:p>
             <a:pPr algn="l"/>
             <a:r>
-              <a:rPr sz="2400" b="0">
+              <a:rPr sz="2000" b="0">
                 <a:solidFill>
                   <a:srgbClr val="222B27"/>
                 </a:solidFill>
                 <a:latin typeface="Calibri"/>
               </a:rPr>
-              <a:t>Données Québec ouvertes, fichiers de la Ville : structure seulement</a:t>
-            </a:r>
-          </a:p>
-        </p:txBody>
-      </p:sp>
-      <p:sp>
-        <p:nvSpPr>
-          <p:cNvPr id="15" name="TextBox 14"/>
+              <a:t>Répertoires de la Ville (structure seulement) : 614 organismes reconnus, 337 soutenus, 487 entreprises, 386 membres SDC, 1 960 installations, 379 événements</a:t>
+            </a:r>
+          </a:p>
+        </p:txBody>
+      </p:sp>
+      <p:sp>
+        <p:nvSpPr>
+          <p:cNvPr id="15" name="Rounded Rectangle 14"/>
+          <p:cNvSpPr/>
+          <p:nvPr/>
+        </p:nvSpPr>
+        <p:spPr>
+          <a:xfrm>
+            <a:off x="8995179" y="3337560"/>
+            <a:ext cx="2556433" cy="2377440"/>
+          </a:xfrm>
+          <a:prstGeom prst="roundRect">
+            <a:avLst/>
+          </a:prstGeom>
+          <a:solidFill>
+            <a:srgbClr val="FFFFFF"/>
+          </a:solidFill>
+          <a:ln>
+            <a:noFill/>
+          </a:ln>
+          <a:effectLst/>
+        </p:spPr>
+        <p:style>
+          <a:lnRef idx="1">
+            <a:schemeClr val="accent1"/>
+          </a:lnRef>
+          <a:fillRef idx="3">
+            <a:schemeClr val="accent1"/>
+          </a:fillRef>
+          <a:effectRef idx="2">
+            <a:schemeClr val="accent1"/>
+          </a:effectRef>
+          <a:fontRef idx="minor">
+            <a:schemeClr val="lt1"/>
+          </a:fontRef>
+        </p:style>
+        <p:txBody>
+          <a:bodyPr rtlCol="0" anchor="ctr"/>
+          <a:lstStyle/>
+          <a:p>
+            <a:pPr algn="ctr"/>
+          </a:p>
+        </p:txBody>
+      </p:sp>
+      <p:sp>
+        <p:nvSpPr>
+          <p:cNvPr id="16" name="Rectangle 15"/>
+          <p:cNvSpPr/>
+          <p:nvPr/>
+        </p:nvSpPr>
+        <p:spPr>
+          <a:xfrm>
+            <a:off x="8995179" y="3337560"/>
+            <a:ext cx="2556433" cy="109728"/>
+          </a:xfrm>
+          <a:prstGeom prst="rect">
+            <a:avLst/>
+          </a:prstGeom>
+          <a:solidFill>
+            <a:srgbClr val="E8833A"/>
+          </a:solidFill>
+          <a:ln>
+            <a:noFill/>
+          </a:ln>
+          <a:effectLst/>
+        </p:spPr>
+        <p:style>
+          <a:lnRef idx="1">
+            <a:schemeClr val="accent1"/>
+          </a:lnRef>
+          <a:fillRef idx="3">
+            <a:schemeClr val="accent1"/>
+          </a:fillRef>
+          <a:effectRef idx="2">
+            <a:schemeClr val="accent1"/>
+          </a:effectRef>
+          <a:fontRef idx="minor">
+            <a:schemeClr val="lt1"/>
+          </a:fontRef>
+        </p:style>
+        <p:txBody>
+          <a:bodyPr rtlCol="0" anchor="ctr"/>
+          <a:lstStyle/>
+          <a:p>
+            <a:pPr algn="ctr"/>
+          </a:p>
+        </p:txBody>
+      </p:sp>
+      <p:sp>
+        <p:nvSpPr>
+          <p:cNvPr id="17" name="TextBox 16"/>
+          <p:cNvSpPr txBox="1"/>
+          <p:nvPr/>
+        </p:nvSpPr>
+        <p:spPr>
+          <a:xfrm>
+            <a:off x="9178059" y="3566160"/>
+            <a:ext cx="2190673" cy="2011680"/>
+          </a:xfrm>
+          <a:prstGeom prst="rect">
+            <a:avLst/>
+          </a:prstGeom>
+          <a:noFill/>
+        </p:spPr>
+        <p:txBody>
+          <a:bodyPr wrap="square" anchor="ctr">
+            <a:spAutoFit/>
+          </a:bodyPr>
+          <a:lstStyle/>
+          <a:p>
+            <a:pPr algn="l"/>
+            <a:r>
+              <a:rPr sz="2000" b="0">
+                <a:solidFill>
+                  <a:srgbClr val="222B27"/>
+                </a:solidFill>
+                <a:latin typeface="Calibri"/>
+              </a:rPr>
+              <a:t>Données Québec ouvertes</a:t>
+            </a:r>
+          </a:p>
+        </p:txBody>
+      </p:sp>
+      <p:sp>
+        <p:nvSpPr>
+          <p:cNvPr id="18" name="TextBox 17"/>
           <p:cNvSpPr txBox="1"/>
           <p:nvPr/>
         </p:nvSpPr>
@@ -6253,7 +6750,7 @@
       </p:sp>
       <p:sp>
         <p:nvSpPr>
-          <p:cNvPr id="16" name="TextBox 15"/>
+          <p:cNvPr id="19" name="TextBox 18"/>
           <p:cNvSpPr txBox="1"/>
           <p:nvPr/>
         </p:nvSpPr>

</xml_diff>

<commit_message>
fr.ts: corvee_proprete et histoire 2; notes diapo 7
</commit_message>
<xml_diff>
--- a/docs/pitch/Maillage.pptx
+++ b/docs/pitch/Maillage.pptx
@@ -1000,6 +1000,11 @@
           <a:p>
             <a:r>
               <a:t>Signal [CIAN] : portée : « Maillage règle un problème précis, de bout en bout : trouver le bon partenaire, se mettre d’accord, se coordonner et passer à l’action. On s’arrête là où d’autres outils existent (311, 911, plateformes de financement). » Puis coût : « Hébergement gratuit pour un projet pilote, et une personne à temps partiel à la SDC pour l’accueil et la modération. » Dans la démo aucun message ne part; en pilote, la boucle complète est ce qu’on ajoute. (50 s)</a:t>
+            </a:r>
+          </a:p>
+          <a:p>
+            <a:r>
+              <a:t>Histoire 2 (visite guidée ou une diapo, pas en direct) : Sofia, résidente de la rue Saint-Joseph, voit des graffitis et des déchets; Maillage lui propose une « Corvée de propreté avec Équipe Propreté du Faubourg », des bénévoles et un café du coin, avec la liste « autorisation du propriétaire, 311 pour la voie publique ». Noms fictifs.</a:t>
             </a:r>
           </a:p>
           <a:p>

</xml_diff>

<commit_message>
Docs: jury dry-run fixes to pitch, Q&A, demo script, tests, README
Pitch: name and one-line what in the first 10 s, team in the first 20 s,
new pasted demo sentence with reciprocity, Camille accepts live, precise
row-count wording, Loi 25 wording, optional Sofia beat. Slides: 7 slides
(old slide 4 dropped), quote placeholder, GitHub Pages link. Q&A: 8 new
answers plus extras. DEMO-SCRIPT/TESTS: GitHub Pages, 57 s tour, new
sentence, clear site data step. README in French. CLAUDE.md data table.

Co-Authored-By: Claude Opus 5.5 <noreply@anthropic.com>
Claude-Session: https://claude.ai/code/session_01Ee4731zPTWaYnY94BTHWYd
</commit_message>
<xml_diff>
--- a/docs/pitch/Maillage.pptx
+++ b/docs/pitch/Maillage.pptx
@@ -12,7 +12,6 @@
     <p:sldId id="260" r:id="rId12"/>
     <p:sldId id="261" r:id="rId13"/>
     <p:sldId id="262" r:id="rId14"/>
-    <p:sldId id="263" r:id="rId15"/>
   </p:sldIdLst>
   <p:sldSz cx="12191695" cy="6858000" type="screen4x3"/>
   <p:notesSz cx="6858000" cy="9144000"/>
@@ -589,7 +588,12 @@
           </a:p>
           <a:p>
             <a:r>
-              <a:t>Signal [COÉQUIPIÈRE] : histoire de Mathieu (Café Le Petit Détour), de Camille Vézina et du Collectif Les Voisins en Scène. Finir par « Personne ne sait que les autres existent. » (40 s)</a:t>
+              <a:t>Ce qu’on a entendu : une seule vraie citation d’un commerçant rencontré vendredi matin, à écrire sur la diapo avant l’export PDF de 12 h 30. Si on n’a rien de vrai, retirer la carte : ne jamais inventer une citation.</a:t>
+            </a:r>
+          </a:p>
+          <a:p>
+            <a:r>
+              <a:t>Signal [COÉQUIPIÈRE] : histoire de Mathieu (Café Le Petit Détour), de Camille Vézina et du Collectif Les Voisins en Scène. Finir par « Personne ne sait que les deux autres existent. » (30 s)</a:t>
             </a:r>
           </a:p>
         </p:txBody>
@@ -664,7 +668,7 @@
           </a:p>
           <a:p>
             <a:r>
-              <a:t>Signal [CIAN] : « Voici Maillage », puis passer au téléphone pour la démo. (1 min 45 s avec la démo)</a:t>
+              <a:t>Signal [CIAN] : « Voyons comment ça marche », puis passer à l’app : coller la phrase « On a un espace libre le jeudi soir et on cherche des artistes pour l’animer », 87 % avec Camille Vézina et le Collectif Les Voisins en Scène, dire la réciprocité, puis « Voir ce que Camille reçoit » et « Accepter ». Si l’app plante : Visite guidée (environ 57 s). (1 min 50 s avec la démo)</a:t>
             </a:r>
           </a:p>
         </p:txBody>
@@ -734,12 +738,27 @@
           <a:lstStyle/>
           <a:p>
             <a:r>
-              <a:t>Visuel : les 5 étapes en frise, badge « Démo simulée ».</a:t>
-            </a:r>
-          </a:p>
-          <a:p>
-            <a:r>
-              <a:t>Signal [CIAN] : à garder à l’écran si l’app plante, puis lancer la vidéo de secours. (peut être sautée si le temps manque)</a:t>
+              <a:t>Contenu en trois colonnes :</a:t>
+            </a:r>
+          </a:p>
+          <a:p>
+            <a:r>
+              <a:t>- Technologies : Vite, React, TypeScript, MapLibre GL JS.</a:t>
+            </a:r>
+          </a:p>
+          <a:p>
+            <a:r>
+              <a:t>- Outils et plateformes : OpenFreeMap et OpenStreetMap (fond de carte), GitHub Pages (hébergement; Vercel en secours), GitHub (code), Claude Code comme assistant de développement.</a:t>
+            </a:r>
+          </a:p>
+          <a:p>
+            <a:r>
+              <a:t>- Données : Données Québec, données ouvertes de la Ville de Québec et du SIT Québec (CC BY 4.0, attribution dans l’app). Fichiers fournis confidentiels : structure et nombre de lignes seulement, remplacés par des profils fictifs dans la démo. Les nombres sont des totaux de lignes : « les 386 membres du fichier fourni par la SDC », « 614 organismes reconnus à l’échelle de la ville » (jamais « dans Saint-Roch » pour un fichier de toute la ville).</a:t>
+            </a:r>
+          </a:p>
+          <a:p>
+            <a:r>
+              <a:t>Signal [CIAN] : dire « Maillage part des répertoires qui existent déjà : les 386 membres du fichier fourni par la SDC, et 614 organismes reconnus à l’échelle de la ville. Personne ne commence avec une page blanche. » Puis la Loi 25 : « les personnes restent cachées; les commerces et organismes apparaissent avec leur nom public seulement, sans coordonnées, étiquetés pré-remplis, jusqu’à activation ». Nos règles s’appuient aussi sur le Plan d’action Saint-Roch. (35 s)</a:t>
             </a:r>
           </a:p>
         </p:txBody>
@@ -809,27 +828,12 @@
           <a:lstStyle/>
           <a:p>
             <a:r>
-              <a:t>Contenu en trois colonnes :</a:t>
-            </a:r>
-          </a:p>
-          <a:p>
-            <a:r>
-              <a:t>- Technologies : Vite, React, TypeScript, MapLibre GL JS.</a:t>
-            </a:r>
-          </a:p>
-          <a:p>
-            <a:r>
-              <a:t>- Outils et plateformes : OpenFreeMap et OpenStreetMap (fond de carte), Vercel (hébergement), GitHub (code), Claude Code comme assistant de développement.</a:t>
-            </a:r>
-          </a:p>
-          <a:p>
-            <a:r>
-              <a:t>- Données : Données Québec, données ouvertes (licence indiquée dans l’app, à reprendre exactement de chaque jeu de données). Fichiers confidentiels de la Ville : utilisés pour leur structure seulement, remplacés par des lignes fictives dans la démo.</a:t>
-            </a:r>
-          </a:p>
-          <a:p>
-            <a:r>
-              <a:t>Signal [CIAN] : trois idées seulement : profils cachés tant que non réclamés, fichiers confidentiels non publiés, structure prête pour la Ville. Dire : « La Ville et ses partenaires recensent déjà 614 organismes reconnus, 337 organismes soutenus, 487 entreprises dans Saint-Roch, 386 membres de la SDC, 1 960 installations et 379 événements à venir. Maillage part de ces répertoires : personne ne commence avec une page blanche. » Nos règles s’appuient aussi sur le Plan d’action Saint-Roch. (35 s)</a:t>
+              <a:t>Visuel : une carte de proposition avec « Pourquoi cette suggestion » et « À confirmer » surlignés; en bas, en petit : « Chaque suggestion s’explique. » Notes du test d’IA (pas sur la diapo, à voix haute seulement si on veut) : « Modèle multilingue dans le navigateur, gratuit, texte sur l’appareil (page /labo/) : 69 s au premier chargement (129 Mo), 13 s ensuite, 0,3 à 0,6 s par phrase. Trouve des profils semblables, pas complémentaires. »</a:t>
+            </a:r>
+          </a:p>
+          <a:p>
+            <a:r>
+              <a:t>Signal [COÉQUIPIÈRE] : verdict d’abord : on l’a testé, on a choisi des règles pour que chaque suggestion s’explique. Chiffres du test seulement si le jury demande. (20 s)</a:t>
             </a:r>
           </a:p>
         </p:txBody>
@@ -899,12 +903,42 @@
           <a:lstStyle/>
           <a:p>
             <a:r>
-              <a:t>Visuel : une carte de proposition avec « Pourquoi cette suggestion » et « À confirmer » surlignés; en bas, en petit : « Chaque suggestion s’explique. » Notes du test d’IA (pas sur la diapo, à voix haute seulement si on veut) : « Modèle multilingue dans le navigateur, gratuit, texte sur l’appareil (page /labo/) : 69 s au premier chargement (129 Mo), 13 s ensuite, 0,3 à 0,6 s par phrase. Trouve des profils semblables, pas complémentaires. »</a:t>
-            </a:r>
-          </a:p>
-          <a:p>
-            <a:r>
-              <a:t>Signal [COÉQUIPIÈRE] : verdict d’abord : on l’a testé, on a choisi des règles pour que chaque suggestion s’explique. Chiffres du test seulement si le jury demande. (35 s)</a:t>
+              <a:t>Feuille de route en trois temps :</a:t>
+            </a:r>
+          </a:p>
+          <a:p>
+            <a:r>
+              <a:t>- Maintenant : démo avec profils fictifs et données ouvertes.</a:t>
+            </a:r>
+          </a:p>
+          <a:p>
+            <a:r>
+              <a:t>- Ensuite : pilote avec la SDC, profils activés par leurs propriétaires, vraies notifications, fil de projet sur une table gratuite derrière le même écran, modérée par la SDC.</a:t>
+            </a:r>
+          </a:p>
+          <a:p>
+            <a:r>
+              <a:t>- Plus tard : modèle de langage pour lire les demandes, autres quartiers.</a:t>
+            </a:r>
+          </a:p>
+          <a:p>
+            <a:r>
+              <a:t>Mesures : projets confirmés, nouveaux partenariats, fréquentation des événements créés.</a:t>
+            </a:r>
+          </a:p>
+          <a:p>
+            <a:r>
+              <a:t>Signal [CIAN] : portée : « Maillage règle un problème précis : trouver le bon partenaire, se mettre d’accord et passer à l’action. On s’arrête là où d’autres outils existent : 311, 911, financement. » Puis le fil : « Le fil est local aujourd’hui; en pilote, une table gratuite derrière le même écran, modérée par la SDC. » Puis coût : « Le pilote coûte un hébergement gratuit et une personne à temps partiel à la SDC. » (55 s)</a:t>
+            </a:r>
+          </a:p>
+          <a:p>
+            <a:r>
+              <a:t>Histoire 2 (en direct seulement si le temps le permet, voir script-fr.md, démo étape 6 : Accueil, Proposer un projet, Exemple, Avant de commencer) : Sofia, résidente de la rue Saint-Joseph, corvée le samedi 24 octobre de 13 h à 17 h, voit des graffitis et des déchets; Maillage lui propose une « Corvée de propreté avec Équipe Propreté du Faubourg », des bénévoles et un café du coin, avec la liste « autorisation du propriétaire, 311 pour la voie publique ». Noms fictifs.</a:t>
+            </a:r>
+          </a:p>
+          <a:p>
+            <a:r>
+              <a:t>À ajouter à la feuille de route seulement si non démontré en direct : Explorer le quartier, profils publics, fil de projet, projets ouverts.</a:t>
             </a:r>
           </a:p>
         </p:txBody>
@@ -974,112 +1008,7 @@
           <a:lstStyle/>
           <a:p>
             <a:r>
-              <a:t>Feuille de route en trois temps :</a:t>
-            </a:r>
-          </a:p>
-          <a:p>
-            <a:r>
-              <a:t>- Maintenant : démo avec profils fictifs et données ouvertes.</a:t>
-            </a:r>
-          </a:p>
-          <a:p>
-            <a:r>
-              <a:t>- Ensuite : pilote avec la SDC, profils réclamés par leurs propriétaires, vraies notifications.</a:t>
-            </a:r>
-          </a:p>
-          <a:p>
-            <a:r>
-              <a:t>- Plus tard : modèle de langage pour lire les demandes, autres quartiers.</a:t>
-            </a:r>
-          </a:p>
-          <a:p>
-            <a:r>
-              <a:t>Mesures : projets confirmés, nouveaux partenariats, fréquentation des événements créés.</a:t>
-            </a:r>
-          </a:p>
-          <a:p>
-            <a:r>
-              <a:t>Signal [CIAN] : portée : « Maillage règle un problème précis, de bout en bout : trouver le bon partenaire, se mettre d’accord, se coordonner et passer à l’action. On s’arrête là où d’autres outils existent (311, 911, plateformes de financement). » Puis coût : « Hébergement gratuit pour un projet pilote, et une personne à temps partiel à la SDC pour l’accueil et la modération. » Dans la démo aucun message ne part; en pilote, la boucle complète est ce qu’on ajoute. (50 s)</a:t>
-            </a:r>
-          </a:p>
-          <a:p>
-            <a:r>
-              <a:t>Histoire 2 (visite guidée ou une diapo, pas en direct) : Sofia, résidente de la rue Saint-Joseph, voit des graffitis et des déchets; Maillage lui propose une « Corvée de propreté avec Équipe Propreté du Faubourg », des bénévoles et un café du coin, avec la liste « autorisation du propriétaire, 311 pour la voie publique ». Noms fictifs.</a:t>
-            </a:r>
-          </a:p>
-          <a:p>
-            <a:r>
-              <a:t>À ajouter à la feuille de route seulement si non démontré en direct : Explorer le quartier, profils publics, fil de projet, projets ouverts.</a:t>
-            </a:r>
-          </a:p>
-        </p:txBody>
-      </p:sp>
-      <p:sp>
-        <p:nvSpPr>
-          <p:cNvPr id="4" name="Slide Number Placeholder 3"/>
-          <p:cNvSpPr>
-            <a:spLocks noGrp="1"/>
-          </p:cNvSpPr>
-          <p:nvPr>
-            <p:ph type="sldNum" idx="5" sz="quarter"/>
-          </p:nvPr>
-        </p:nvSpPr>
-        <p:spPr/>
-      </p:sp>
-    </p:spTree>
-  </p:cSld>
-  <p:clrMapOvr>
-    <a:masterClrMapping/>
-  </p:clrMapOvr>
-</p:notes>
-</file>
-
-<file path=ppt/notesSlides/notesSlide8.xml><?xml version="1.0" encoding="utf-8"?>
-<p:notes xmlns:a="http://schemas.openxmlformats.org/drawingml/2006/main" xmlns:p="http://schemas.openxmlformats.org/presentationml/2006/main" xmlns:r="http://schemas.openxmlformats.org/officeDocument/2006/relationships">
-  <p:cSld>
-    <p:spTree>
-      <p:nvGrpSpPr>
-        <p:cNvPr id="1" name=""/>
-        <p:cNvGrpSpPr/>
-        <p:nvPr/>
-      </p:nvGrpSpPr>
-      <p:grpSpPr>
-        <a:xfrm>
-          <a:off x="0" y="0"/>
-          <a:ext cx="0" cy="0"/>
-          <a:chOff x="0" y="0"/>
-          <a:chExt cx="0" cy="0"/>
-        </a:xfrm>
-      </p:grpSpPr>
-      <p:sp>
-        <p:nvSpPr>
-          <p:cNvPr id="2" name="Slide Image Placeholder 1"/>
-          <p:cNvSpPr>
-            <a:spLocks noGrp="1"/>
-          </p:cNvSpPr>
-          <p:nvPr>
-            <p:ph type="sldImg" idx="2"/>
-          </p:nvPr>
-        </p:nvSpPr>
-        <p:spPr/>
-      </p:sp>
-      <p:sp>
-        <p:nvSpPr>
-          <p:cNvPr id="3" name="Notes Placeholder 2"/>
-          <p:cNvSpPr>
-            <a:spLocks noGrp="1"/>
-          </p:cNvSpPr>
-          <p:nvPr>
-            <p:ph type="body" idx="3" sz="quarter"/>
-          </p:nvPr>
-        </p:nvSpPr>
-        <p:spPr/>
-        <p:txBody>
-          <a:bodyPr/>
-          <a:lstStyle/>
-          <a:p>
-            <a:r>
-              <a:t>Visuel : la carte, les trois points reliés, l’adresse de l’app (code QR).</a:t>
+              <a:t>Visuel : la carte, les trois points reliés, code QR vers https://cianthiffault2006-png.github.io/hackathon-saint-roch-2026/ (lien officiel, GitHub Pages). Ne pas mettre le lien Vercel : il est figé sur une ancienne version.</a:t>
             </a:r>
           </a:p>
           <a:p>
@@ -4489,7 +4418,7 @@
         <p:spPr>
           <a:xfrm>
             <a:off x="640080" y="3337560"/>
-            <a:ext cx="3484778" cy="2377440"/>
+            <a:ext cx="2556433" cy="2377440"/>
           </a:xfrm>
           <a:prstGeom prst="roundRect">
             <a:avLst/>
@@ -4533,7 +4462,7 @@
         <p:spPr>
           <a:xfrm>
             <a:off x="640080" y="3337560"/>
-            <a:ext cx="3484778" cy="109728"/>
+            <a:ext cx="2556433" cy="109728"/>
           </a:xfrm>
           <a:prstGeom prst="rect">
             <a:avLst/>
@@ -4577,7 +4506,7 @@
         <p:spPr>
           <a:xfrm>
             <a:off x="822960" y="3566160"/>
-            <a:ext cx="3119018" cy="2011680"/>
+            <a:ext cx="2190673" cy="2011680"/>
           </a:xfrm>
           <a:prstGeom prst="rect">
             <a:avLst/>
@@ -4592,7 +4521,7 @@
           <a:p>
             <a:pPr algn="l"/>
             <a:r>
-              <a:rPr sz="2400" b="0">
+              <a:rPr sz="2000" b="0">
                 <a:solidFill>
                   <a:srgbClr val="222B27"/>
                 </a:solidFill>
@@ -4611,8 +4540,8 @@
         </p:nvSpPr>
         <p:spPr>
           <a:xfrm>
-            <a:off x="4353458" y="3337560"/>
-            <a:ext cx="3484778" cy="2377440"/>
+            <a:off x="3425113" y="3337560"/>
+            <a:ext cx="2556433" cy="2377440"/>
           </a:xfrm>
           <a:prstGeom prst="roundRect">
             <a:avLst/>
@@ -4655,8 +4584,8 @@
         </p:nvSpPr>
         <p:spPr>
           <a:xfrm>
-            <a:off x="4353458" y="3337560"/>
-            <a:ext cx="3484778" cy="109728"/>
+            <a:off x="3425113" y="3337560"/>
+            <a:ext cx="2556433" cy="109728"/>
           </a:xfrm>
           <a:prstGeom prst="rect">
             <a:avLst/>
@@ -4699,8 +4628,8 @@
         </p:nvSpPr>
         <p:spPr>
           <a:xfrm>
-            <a:off x="4536338" y="3566160"/>
-            <a:ext cx="3119018" cy="2011680"/>
+            <a:off x="3607993" y="3566160"/>
+            <a:ext cx="2190673" cy="2011680"/>
           </a:xfrm>
           <a:prstGeom prst="rect">
             <a:avLst/>
@@ -4715,7 +4644,7 @@
           <a:p>
             <a:pPr algn="l"/>
             <a:r>
-              <a:rPr sz="2400" b="0">
+              <a:rPr sz="2000" b="0">
                 <a:solidFill>
                   <a:srgbClr val="222B27"/>
                 </a:solidFill>
@@ -4734,8 +4663,8 @@
         </p:nvSpPr>
         <p:spPr>
           <a:xfrm>
-            <a:off x="8066836" y="3337560"/>
-            <a:ext cx="3484778" cy="2377440"/>
+            <a:off x="6210146" y="3337560"/>
+            <a:ext cx="2556433" cy="2377440"/>
           </a:xfrm>
           <a:prstGeom prst="roundRect">
             <a:avLst/>
@@ -4778,8 +4707,8 @@
         </p:nvSpPr>
         <p:spPr>
           <a:xfrm>
-            <a:off x="8066836" y="3337560"/>
-            <a:ext cx="3484778" cy="109728"/>
+            <a:off x="6210146" y="3337560"/>
+            <a:ext cx="2556433" cy="109728"/>
           </a:xfrm>
           <a:prstGeom prst="rect">
             <a:avLst/>
@@ -4822,8 +4751,8 @@
         </p:nvSpPr>
         <p:spPr>
           <a:xfrm>
-            <a:off x="8249716" y="3566160"/>
-            <a:ext cx="3119018" cy="2011680"/>
+            <a:off x="6393026" y="3566160"/>
+            <a:ext cx="2190673" cy="2011680"/>
           </a:xfrm>
           <a:prstGeom prst="rect">
             <a:avLst/>
@@ -4838,7 +4767,7 @@
           <a:p>
             <a:pPr algn="l"/>
             <a:r>
-              <a:rPr sz="2400" b="0">
+              <a:rPr sz="2000" b="0">
                 <a:solidFill>
                   <a:srgbClr val="222B27"/>
                 </a:solidFill>
@@ -4851,7 +4780,130 @@
       </p:sp>
       <p:sp>
         <p:nvSpPr>
-          <p:cNvPr id="15" name="TextBox 14"/>
+          <p:cNvPr id="15" name="Rounded Rectangle 14"/>
+          <p:cNvSpPr/>
+          <p:nvPr/>
+        </p:nvSpPr>
+        <p:spPr>
+          <a:xfrm>
+            <a:off x="8995179" y="3337560"/>
+            <a:ext cx="2556433" cy="2377440"/>
+          </a:xfrm>
+          <a:prstGeom prst="roundRect">
+            <a:avLst/>
+          </a:prstGeom>
+          <a:solidFill>
+            <a:srgbClr val="FFFFFF"/>
+          </a:solidFill>
+          <a:ln>
+            <a:noFill/>
+          </a:ln>
+          <a:effectLst/>
+        </p:spPr>
+        <p:style>
+          <a:lnRef idx="1">
+            <a:schemeClr val="accent1"/>
+          </a:lnRef>
+          <a:fillRef idx="3">
+            <a:schemeClr val="accent1"/>
+          </a:fillRef>
+          <a:effectRef idx="2">
+            <a:schemeClr val="accent1"/>
+          </a:effectRef>
+          <a:fontRef idx="minor">
+            <a:schemeClr val="lt1"/>
+          </a:fontRef>
+        </p:style>
+        <p:txBody>
+          <a:bodyPr rtlCol="0" anchor="ctr"/>
+          <a:lstStyle/>
+          <a:p>
+            <a:pPr algn="ctr"/>
+          </a:p>
+        </p:txBody>
+      </p:sp>
+      <p:sp>
+        <p:nvSpPr>
+          <p:cNvPr id="16" name="Rectangle 15"/>
+          <p:cNvSpPr/>
+          <p:nvPr/>
+        </p:nvSpPr>
+        <p:spPr>
+          <a:xfrm>
+            <a:off x="8995179" y="3337560"/>
+            <a:ext cx="2556433" cy="109728"/>
+          </a:xfrm>
+          <a:prstGeom prst="rect">
+            <a:avLst/>
+          </a:prstGeom>
+          <a:solidFill>
+            <a:srgbClr val="E8833A"/>
+          </a:solidFill>
+          <a:ln>
+            <a:noFill/>
+          </a:ln>
+          <a:effectLst/>
+        </p:spPr>
+        <p:style>
+          <a:lnRef idx="1">
+            <a:schemeClr val="accent1"/>
+          </a:lnRef>
+          <a:fillRef idx="3">
+            <a:schemeClr val="accent1"/>
+          </a:fillRef>
+          <a:effectRef idx="2">
+            <a:schemeClr val="accent1"/>
+          </a:effectRef>
+          <a:fontRef idx="minor">
+            <a:schemeClr val="lt1"/>
+          </a:fontRef>
+        </p:style>
+        <p:txBody>
+          <a:bodyPr rtlCol="0" anchor="ctr"/>
+          <a:lstStyle/>
+          <a:p>
+            <a:pPr algn="ctr"/>
+          </a:p>
+        </p:txBody>
+      </p:sp>
+      <p:sp>
+        <p:nvSpPr>
+          <p:cNvPr id="17" name="TextBox 16"/>
+          <p:cNvSpPr txBox="1"/>
+          <p:nvPr/>
+        </p:nvSpPr>
+        <p:spPr>
+          <a:xfrm>
+            <a:off x="9178059" y="3566160"/>
+            <a:ext cx="2190673" cy="2011680"/>
+          </a:xfrm>
+          <a:prstGeom prst="rect">
+            <a:avLst/>
+          </a:prstGeom>
+          <a:noFill/>
+        </p:spPr>
+        <p:txBody>
+          <a:bodyPr wrap="square" anchor="ctr">
+            <a:spAutoFit/>
+          </a:bodyPr>
+          <a:lstStyle/>
+          <a:p>
+            <a:pPr algn="l"/>
+            <a:r>
+              <a:rPr sz="2000" b="0">
+                <a:solidFill>
+                  <a:srgbClr val="222B27"/>
+                </a:solidFill>
+                <a:latin typeface="Calibri"/>
+              </a:rPr>
+              <a:t>Ce qu’on a entendu : [À REMPLIR VENDREDI MATIN]</a:t>
+            </a:r>
+          </a:p>
+        </p:txBody>
+      </p:sp>
+      <p:sp>
+        <p:nvSpPr>
+          <p:cNvPr id="18" name="TextBox 17"/>
           <p:cNvSpPr txBox="1"/>
           <p:nvPr/>
         </p:nvSpPr>
@@ -4886,7 +4938,7 @@
       </p:sp>
       <p:sp>
         <p:nvSpPr>
-          <p:cNvPr id="16" name="TextBox 15"/>
+          <p:cNvPr id="19" name="TextBox 18"/>
           <p:cNvSpPr txBox="1"/>
           <p:nvPr/>
         </p:nvSpPr>
@@ -5273,7 +5325,7 @@
                 </a:solidFill>
                 <a:latin typeface="Calibri"/>
               </a:rPr>
-              <a:t>Ce que la démo montre</a:t>
+              <a:t>Technologies, outils et données utilisés</a:t>
             </a:r>
           </a:p>
         </p:txBody>
@@ -5352,7 +5404,7 @@
                 </a:solidFill>
                 <a:latin typeface="Calibri"/>
               </a:rPr>
-              <a:t>Commerçant, besoin, proposition à trois (87 %), Ça m’intéresse, projet confirmé (simulé).</a:t>
+              <a:t>Personne ne commence avec une page blanche.</a:t>
             </a:r>
           </a:p>
         </p:txBody>
@@ -5475,7 +5527,7 @@
                 </a:solidFill>
                 <a:latin typeface="Calibri"/>
               </a:rPr>
-              <a:t>Commerçant</a:t>
+              <a:t>React, Vite, TypeScript, MapLibre</a:t>
             </a:r>
           </a:p>
         </p:txBody>
@@ -5598,7 +5650,7 @@
                 </a:solidFill>
                 <a:latin typeface="Calibri"/>
               </a:rPr>
-              <a:t>Besoin</a:t>
+              <a:t>GitHub Pages, Claude Code</a:t>
             </a:r>
           </a:p>
         </p:txBody>
@@ -5721,7 +5773,7 @@
                 </a:solidFill>
                 <a:latin typeface="Calibri"/>
               </a:rPr>
-              <a:t>Proposition à trois</a:t>
+              <a:t>386 membres (fichier fourni par la SDC)</a:t>
             </a:r>
           </a:p>
         </p:txBody>
@@ -5844,7 +5896,7 @@
                 </a:solidFill>
                 <a:latin typeface="Calibri"/>
               </a:rPr>
-              <a:t>Ça m’intéresse</a:t>
+              <a:t>614 organismes reconnus (toute la ville)</a:t>
             </a:r>
           </a:p>
         </p:txBody>
@@ -5967,7 +6019,7 @@
                 </a:solidFill>
                 <a:latin typeface="Calibri"/>
               </a:rPr>
-              <a:t>Confirmé (simulé)</a:t>
+              <a:t>Données Québec, CC BY 4.0</a:t>
             </a:r>
           </a:p>
         </p:txBody>
@@ -6142,7 +6194,7 @@
                 </a:solidFill>
                 <a:latin typeface="Calibri"/>
               </a:rPr>
-              <a:t>Technologies, outils et données utilisés</a:t>
+              <a:t>Transparence : un moteur de règles, l’IA en phase 2</a:t>
             </a:r>
           </a:p>
         </p:txBody>
@@ -6221,7 +6273,7 @@
                 </a:solidFill>
                 <a:latin typeface="Calibri"/>
               </a:rPr>
-              <a:t>Personne ne commence avec une page blanche.</a:t>
+              <a:t>On l’a testé, on a choisi des règles pour que chaque suggestion s’explique.</a:t>
             </a:r>
           </a:p>
         </p:txBody>
@@ -6235,7 +6287,7 @@
         <p:spPr>
           <a:xfrm>
             <a:off x="640080" y="3337560"/>
-            <a:ext cx="2556433" cy="2377440"/>
+            <a:ext cx="3484778" cy="2377440"/>
           </a:xfrm>
           <a:prstGeom prst="roundRect">
             <a:avLst/>
@@ -6279,7 +6331,7 @@
         <p:spPr>
           <a:xfrm>
             <a:off x="640080" y="3337560"/>
-            <a:ext cx="2556433" cy="109728"/>
+            <a:ext cx="3484778" cy="109728"/>
           </a:xfrm>
           <a:prstGeom prst="rect">
             <a:avLst/>
@@ -6323,7 +6375,7 @@
         <p:spPr>
           <a:xfrm>
             <a:off x="822960" y="3566160"/>
-            <a:ext cx="2190673" cy="2011680"/>
+            <a:ext cx="3119018" cy="2011680"/>
           </a:xfrm>
           <a:prstGeom prst="rect">
             <a:avLst/>
@@ -6338,13 +6390,13 @@
           <a:p>
             <a:pPr algn="l"/>
             <a:r>
-              <a:rPr sz="2000" b="0">
+              <a:rPr sz="2400" b="0">
                 <a:solidFill>
                   <a:srgbClr val="222B27"/>
                 </a:solidFill>
                 <a:latin typeface="Calibri"/>
               </a:rPr>
-              <a:t>Vite, React, TypeScript, MapLibre</a:t>
+              <a:t>Règles visibles</a:t>
             </a:r>
           </a:p>
         </p:txBody>
@@ -6357,8 +6409,8 @@
         </p:nvSpPr>
         <p:spPr>
           <a:xfrm>
-            <a:off x="3425113" y="3337560"/>
-            <a:ext cx="2556433" cy="2377440"/>
+            <a:off x="4353458" y="3337560"/>
+            <a:ext cx="3484778" cy="2377440"/>
           </a:xfrm>
           <a:prstGeom prst="roundRect">
             <a:avLst/>
@@ -6401,8 +6453,8 @@
         </p:nvSpPr>
         <p:spPr>
           <a:xfrm>
-            <a:off x="3425113" y="3337560"/>
-            <a:ext cx="2556433" cy="109728"/>
+            <a:off x="4353458" y="3337560"/>
+            <a:ext cx="3484778" cy="109728"/>
           </a:xfrm>
           <a:prstGeom prst="rect">
             <a:avLst/>
@@ -6445,8 +6497,8 @@
         </p:nvSpPr>
         <p:spPr>
           <a:xfrm>
-            <a:off x="3607993" y="3566160"/>
-            <a:ext cx="2190673" cy="2011680"/>
+            <a:off x="4536338" y="3566160"/>
+            <a:ext cx="3119018" cy="2011680"/>
           </a:xfrm>
           <a:prstGeom prst="rect">
             <a:avLst/>
@@ -6461,13 +6513,13 @@
           <a:p>
             <a:pPr algn="l"/>
             <a:r>
-              <a:rPr sz="2000" b="0">
+              <a:rPr sz="2400" b="0">
                 <a:solidFill>
                   <a:srgbClr val="222B27"/>
                 </a:solidFill>
                 <a:latin typeface="Calibri"/>
               </a:rPr>
-              <a:t>OpenFreeMap, OpenStreetMap, Vercel, GitHub, Claude Code</a:t>
+              <a:t>Score pondéré visible</a:t>
             </a:r>
           </a:p>
         </p:txBody>
@@ -6480,8 +6532,8 @@
         </p:nvSpPr>
         <p:spPr>
           <a:xfrm>
-            <a:off x="6210146" y="3337560"/>
-            <a:ext cx="2556433" cy="2377440"/>
+            <a:off x="8066836" y="3337560"/>
+            <a:ext cx="3484778" cy="2377440"/>
           </a:xfrm>
           <a:prstGeom prst="roundRect">
             <a:avLst/>
@@ -6524,8 +6576,8 @@
         </p:nvSpPr>
         <p:spPr>
           <a:xfrm>
-            <a:off x="6210146" y="3337560"/>
-            <a:ext cx="2556433" cy="109728"/>
+            <a:off x="8066836" y="3337560"/>
+            <a:ext cx="3484778" cy="109728"/>
           </a:xfrm>
           <a:prstGeom prst="rect">
             <a:avLst/>
@@ -6568,8 +6620,8 @@
         </p:nvSpPr>
         <p:spPr>
           <a:xfrm>
-            <a:off x="6393026" y="3566160"/>
-            <a:ext cx="2190673" cy="2011680"/>
+            <a:off x="8249716" y="3566160"/>
+            <a:ext cx="3119018" cy="2011680"/>
           </a:xfrm>
           <a:prstGeom prst="rect">
             <a:avLst/>
@@ -6584,143 +6636,20 @@
           <a:p>
             <a:pPr algn="l"/>
             <a:r>
-              <a:rPr sz="2000" b="0">
+              <a:rPr sz="2400" b="0">
                 <a:solidFill>
                   <a:srgbClr val="222B27"/>
                 </a:solidFill>
                 <a:latin typeface="Calibri"/>
               </a:rPr>
-              <a:t>Répertoires de la Ville (structure seulement) : 614 organismes reconnus, 337 soutenus, 487 entreprises, 386 membres SDC, 1 960 installations, 379 événements</a:t>
-            </a:r>
-          </a:p>
-        </p:txBody>
-      </p:sp>
-      <p:sp>
-        <p:nvSpPr>
-          <p:cNvPr id="15" name="Rounded Rectangle 14"/>
-          <p:cNvSpPr/>
-          <p:nvPr/>
-        </p:nvSpPr>
-        <p:spPr>
-          <a:xfrm>
-            <a:off x="8995179" y="3337560"/>
-            <a:ext cx="2556433" cy="2377440"/>
-          </a:xfrm>
-          <a:prstGeom prst="roundRect">
-            <a:avLst/>
-          </a:prstGeom>
-          <a:solidFill>
-            <a:srgbClr val="FFFFFF"/>
-          </a:solidFill>
-          <a:ln>
-            <a:noFill/>
-          </a:ln>
-          <a:effectLst/>
-        </p:spPr>
-        <p:style>
-          <a:lnRef idx="1">
-            <a:schemeClr val="accent1"/>
-          </a:lnRef>
-          <a:fillRef idx="3">
-            <a:schemeClr val="accent1"/>
-          </a:fillRef>
-          <a:effectRef idx="2">
-            <a:schemeClr val="accent1"/>
-          </a:effectRef>
-          <a:fontRef idx="minor">
-            <a:schemeClr val="lt1"/>
-          </a:fontRef>
-        </p:style>
-        <p:txBody>
-          <a:bodyPr rtlCol="0" anchor="ctr"/>
-          <a:lstStyle/>
-          <a:p>
-            <a:pPr algn="ctr"/>
-          </a:p>
-        </p:txBody>
-      </p:sp>
-      <p:sp>
-        <p:nvSpPr>
-          <p:cNvPr id="16" name="Rectangle 15"/>
-          <p:cNvSpPr/>
-          <p:nvPr/>
-        </p:nvSpPr>
-        <p:spPr>
-          <a:xfrm>
-            <a:off x="8995179" y="3337560"/>
-            <a:ext cx="2556433" cy="109728"/>
-          </a:xfrm>
-          <a:prstGeom prst="rect">
-            <a:avLst/>
-          </a:prstGeom>
-          <a:solidFill>
-            <a:srgbClr val="E8833A"/>
-          </a:solidFill>
-          <a:ln>
-            <a:noFill/>
-          </a:ln>
-          <a:effectLst/>
-        </p:spPr>
-        <p:style>
-          <a:lnRef idx="1">
-            <a:schemeClr val="accent1"/>
-          </a:lnRef>
-          <a:fillRef idx="3">
-            <a:schemeClr val="accent1"/>
-          </a:fillRef>
-          <a:effectRef idx="2">
-            <a:schemeClr val="accent1"/>
-          </a:effectRef>
-          <a:fontRef idx="minor">
-            <a:schemeClr val="lt1"/>
-          </a:fontRef>
-        </p:style>
-        <p:txBody>
-          <a:bodyPr rtlCol="0" anchor="ctr"/>
-          <a:lstStyle/>
-          <a:p>
-            <a:pPr algn="ctr"/>
-          </a:p>
-        </p:txBody>
-      </p:sp>
-      <p:sp>
-        <p:nvSpPr>
-          <p:cNvPr id="17" name="TextBox 16"/>
-          <p:cNvSpPr txBox="1"/>
-          <p:nvPr/>
-        </p:nvSpPr>
-        <p:spPr>
-          <a:xfrm>
-            <a:off x="9178059" y="3566160"/>
-            <a:ext cx="2190673" cy="2011680"/>
-          </a:xfrm>
-          <a:prstGeom prst="rect">
-            <a:avLst/>
-          </a:prstGeom>
-          <a:noFill/>
-        </p:spPr>
-        <p:txBody>
-          <a:bodyPr wrap="square" anchor="ctr">
-            <a:spAutoFit/>
-          </a:bodyPr>
-          <a:lstStyle/>
-          <a:p>
-            <a:pPr algn="l"/>
-            <a:r>
-              <a:rPr sz="2000" b="0">
-                <a:solidFill>
-                  <a:srgbClr val="222B27"/>
-                </a:solidFill>
-                <a:latin typeface="Calibri"/>
-              </a:rPr>
-              <a:t>Données Québec ouvertes</a:t>
-            </a:r>
-          </a:p>
-        </p:txBody>
-      </p:sp>
-      <p:sp>
-        <p:nvSpPr>
-          <p:cNvPr id="18" name="TextBox 17"/>
+              <a:t>Phase 2 : l’IA lit la demande libre</a:t>
+            </a:r>
+          </a:p>
+        </p:txBody>
+      </p:sp>
+      <p:sp>
+        <p:nvSpPr>
+          <p:cNvPr id="15" name="TextBox 14"/>
           <p:cNvSpPr txBox="1"/>
           <p:nvPr/>
         </p:nvSpPr>
@@ -6755,7 +6684,7 @@
       </p:sp>
       <p:sp>
         <p:nvSpPr>
-          <p:cNvPr id="19" name="TextBox 18"/>
+          <p:cNvPr id="16" name="TextBox 15"/>
           <p:cNvSpPr txBox="1"/>
           <p:nvPr/>
         </p:nvSpPr>
@@ -6888,7 +6817,7 @@
                 </a:solidFill>
                 <a:latin typeface="Calibri"/>
               </a:rPr>
-              <a:t>Transparence : un moteur de règles, l’IA en phase 2</a:t>
+              <a:t>Impact et feuille de route</a:t>
             </a:r>
           </a:p>
         </p:txBody>
@@ -6967,7 +6896,7 @@
                 </a:solidFill>
                 <a:latin typeface="Calibri"/>
               </a:rPr>
-              <a:t>On l’a testé, on a choisi des règles pour que chaque suggestion s’explique.</a:t>
+              <a:t>Un pilote avec la SDC, puis tout Saint-Roch.</a:t>
             </a:r>
           </a:p>
         </p:txBody>
@@ -7090,7 +7019,7 @@
                 </a:solidFill>
                 <a:latin typeface="Calibri"/>
               </a:rPr>
-              <a:t>Règles visibles</a:t>
+              <a:t>Maintenant : démo simulée, fil local</a:t>
             </a:r>
           </a:p>
         </p:txBody>
@@ -7213,7 +7142,7 @@
                 </a:solidFill>
                 <a:latin typeface="Calibri"/>
               </a:rPr>
-              <a:t>Score pondéré visible</a:t>
+              <a:t>Pilote : vraie invitation, fil partagé modéré par la SDC</a:t>
             </a:r>
           </a:p>
         </p:txBody>
@@ -7336,7 +7265,7 @@
                 </a:solidFill>
                 <a:latin typeface="Calibri"/>
               </a:rPr>
-              <a:t>Phase 2 : l’IA lit la demande libre</a:t>
+              <a:t>Plus tard : IA, autres quartiers</a:t>
             </a:r>
           </a:p>
         </p:txBody>
@@ -7511,7 +7440,7 @@
                 </a:solidFill>
                 <a:latin typeface="Calibri"/>
               </a:rPr>
-              <a:t>Impact et feuille de route</a:t>
+              <a:t>Conclusion</a:t>
             </a:r>
           </a:p>
         </p:txBody>
@@ -7590,117 +7519,29 @@
                 </a:solidFill>
                 <a:latin typeface="Calibri"/>
               </a:rPr>
-              <a:t>Un pilote avec la SDC, puis tout Saint-Roch.</a:t>
-            </a:r>
-          </a:p>
-        </p:txBody>
-      </p:sp>
-      <p:sp>
-        <p:nvSpPr>
-          <p:cNvPr id="6" name="Rounded Rectangle 5"/>
-          <p:cNvSpPr/>
+              <a:t>Saint-Roch a déjà tout ce qu’il faut. Maillage aide ses voisins à se trouver.</a:t>
+            </a:r>
+          </a:p>
+        </p:txBody>
+      </p:sp>
+      <p:sp>
+        <p:nvSpPr>
+          <p:cNvPr id="6" name="TextBox 5"/>
+          <p:cNvSpPr txBox="1"/>
           <p:nvPr/>
         </p:nvSpPr>
         <p:spPr>
           <a:xfrm>
             <a:off x="640080" y="3337560"/>
-            <a:ext cx="3484778" cy="2377440"/>
-          </a:xfrm>
-          <a:prstGeom prst="roundRect">
-            <a:avLst/>
-          </a:prstGeom>
-          <a:solidFill>
-            <a:srgbClr val="FFFFFF"/>
-          </a:solidFill>
-          <a:ln>
-            <a:noFill/>
-          </a:ln>
-          <a:effectLst/>
-        </p:spPr>
-        <p:style>
-          <a:lnRef idx="1">
-            <a:schemeClr val="accent1"/>
-          </a:lnRef>
-          <a:fillRef idx="3">
-            <a:schemeClr val="accent1"/>
-          </a:fillRef>
-          <a:effectRef idx="2">
-            <a:schemeClr val="accent1"/>
-          </a:effectRef>
-          <a:fontRef idx="minor">
-            <a:schemeClr val="lt1"/>
-          </a:fontRef>
-        </p:style>
-        <p:txBody>
-          <a:bodyPr rtlCol="0" anchor="ctr"/>
-          <a:lstStyle/>
-          <a:p>
-            <a:pPr algn="ctr"/>
-          </a:p>
-        </p:txBody>
-      </p:sp>
-      <p:sp>
-        <p:nvSpPr>
-          <p:cNvPr id="7" name="Rectangle 6"/>
-          <p:cNvSpPr/>
-          <p:nvPr/>
-        </p:nvSpPr>
-        <p:spPr>
-          <a:xfrm>
-            <a:off x="640080" y="3337560"/>
-            <a:ext cx="3484778" cy="109728"/>
+            <a:ext cx="10911535" cy="1371600"/>
           </a:xfrm>
           <a:prstGeom prst="rect">
             <a:avLst/>
           </a:prstGeom>
-          <a:solidFill>
-            <a:srgbClr val="E8833A"/>
-          </a:solidFill>
-          <a:ln>
-            <a:noFill/>
-          </a:ln>
-          <a:effectLst/>
-        </p:spPr>
-        <p:style>
-          <a:lnRef idx="1">
-            <a:schemeClr val="accent1"/>
-          </a:lnRef>
-          <a:fillRef idx="3">
-            <a:schemeClr val="accent1"/>
-          </a:fillRef>
-          <a:effectRef idx="2">
-            <a:schemeClr val="accent1"/>
-          </a:effectRef>
-          <a:fontRef idx="minor">
-            <a:schemeClr val="lt1"/>
-          </a:fontRef>
-        </p:style>
-        <p:txBody>
-          <a:bodyPr rtlCol="0" anchor="ctr"/>
-          <a:lstStyle/>
-          <a:p>
-            <a:pPr algn="ctr"/>
-          </a:p>
-        </p:txBody>
-      </p:sp>
-      <p:sp>
-        <p:nvSpPr>
-          <p:cNvPr id="8" name="TextBox 7"/>
-          <p:cNvSpPr txBox="1"/>
-          <p:nvPr/>
-        </p:nvSpPr>
-        <p:spPr>
-          <a:xfrm>
-            <a:off x="822960" y="3566160"/>
-            <a:ext cx="3119018" cy="2011680"/>
-          </a:xfrm>
-          <a:prstGeom prst="rect">
-            <a:avLst/>
-          </a:prstGeom>
           <a:noFill/>
         </p:spPr>
         <p:txBody>
-          <a:bodyPr wrap="square" anchor="ctr">
+          <a:bodyPr wrap="square" anchor="t">
             <a:spAutoFit/>
           </a:bodyPr>
           <a:lstStyle/>
@@ -7709,264 +7550,18 @@
             <a:r>
               <a:rPr sz="2400" b="0">
                 <a:solidFill>
-                  <a:srgbClr val="222B27"/>
+                  <a:srgbClr val="1F5F4A"/>
                 </a:solidFill>
                 <a:latin typeface="Calibri"/>
               </a:rPr>
-              <a:t>Maintenant : démo simulée</a:t>
-            </a:r>
-          </a:p>
-        </p:txBody>
-      </p:sp>
-      <p:sp>
-        <p:nvSpPr>
-          <p:cNvPr id="9" name="Rounded Rectangle 8"/>
-          <p:cNvSpPr/>
-          <p:nvPr/>
-        </p:nvSpPr>
-        <p:spPr>
-          <a:xfrm>
-            <a:off x="4353458" y="3337560"/>
-            <a:ext cx="3484778" cy="2377440"/>
-          </a:xfrm>
-          <a:prstGeom prst="roundRect">
-            <a:avLst/>
-          </a:prstGeom>
-          <a:solidFill>
-            <a:srgbClr val="FFFFFF"/>
-          </a:solidFill>
-          <a:ln>
-            <a:noFill/>
-          </a:ln>
-          <a:effectLst/>
-        </p:spPr>
-        <p:style>
-          <a:lnRef idx="1">
-            <a:schemeClr val="accent1"/>
-          </a:lnRef>
-          <a:fillRef idx="3">
-            <a:schemeClr val="accent1"/>
-          </a:fillRef>
-          <a:effectRef idx="2">
-            <a:schemeClr val="accent1"/>
-          </a:effectRef>
-          <a:fontRef idx="minor">
-            <a:schemeClr val="lt1"/>
-          </a:fontRef>
-        </p:style>
-        <p:txBody>
-          <a:bodyPr rtlCol="0" anchor="ctr"/>
-          <a:lstStyle/>
-          <a:p>
-            <a:pPr algn="ctr"/>
-          </a:p>
-        </p:txBody>
-      </p:sp>
-      <p:sp>
-        <p:nvSpPr>
-          <p:cNvPr id="10" name="Rectangle 9"/>
-          <p:cNvSpPr/>
-          <p:nvPr/>
-        </p:nvSpPr>
-        <p:spPr>
-          <a:xfrm>
-            <a:off x="4353458" y="3337560"/>
-            <a:ext cx="3484778" cy="109728"/>
-          </a:xfrm>
-          <a:prstGeom prst="rect">
-            <a:avLst/>
-          </a:prstGeom>
-          <a:solidFill>
-            <a:srgbClr val="E8833A"/>
-          </a:solidFill>
-          <a:ln>
-            <a:noFill/>
-          </a:ln>
-          <a:effectLst/>
-        </p:spPr>
-        <p:style>
-          <a:lnRef idx="1">
-            <a:schemeClr val="accent1"/>
-          </a:lnRef>
-          <a:fillRef idx="3">
-            <a:schemeClr val="accent1"/>
-          </a:fillRef>
-          <a:effectRef idx="2">
-            <a:schemeClr val="accent1"/>
-          </a:effectRef>
-          <a:fontRef idx="minor">
-            <a:schemeClr val="lt1"/>
-          </a:fontRef>
-        </p:style>
-        <p:txBody>
-          <a:bodyPr rtlCol="0" anchor="ctr"/>
-          <a:lstStyle/>
-          <a:p>
-            <a:pPr algn="ctr"/>
-          </a:p>
-        </p:txBody>
-      </p:sp>
-      <p:sp>
-        <p:nvSpPr>
-          <p:cNvPr id="11" name="TextBox 10"/>
-          <p:cNvSpPr txBox="1"/>
-          <p:nvPr/>
-        </p:nvSpPr>
-        <p:spPr>
-          <a:xfrm>
-            <a:off x="4536338" y="3566160"/>
-            <a:ext cx="3119018" cy="2011680"/>
-          </a:xfrm>
-          <a:prstGeom prst="rect">
-            <a:avLst/>
-          </a:prstGeom>
-          <a:noFill/>
-        </p:spPr>
-        <p:txBody>
-          <a:bodyPr wrap="square" anchor="ctr">
-            <a:spAutoFit/>
-          </a:bodyPr>
-          <a:lstStyle/>
-          <a:p>
-            <a:pPr algn="l"/>
-            <a:r>
-              <a:rPr sz="2400" b="0">
-                <a:solidFill>
-                  <a:srgbClr val="222B27"/>
-                </a:solidFill>
-                <a:latin typeface="Calibri"/>
-              </a:rPr>
-              <a:t>Pilote : chaque partenaire reçoit l’invitation et accepte</a:t>
-            </a:r>
-          </a:p>
-        </p:txBody>
-      </p:sp>
-      <p:sp>
-        <p:nvSpPr>
-          <p:cNvPr id="12" name="Rounded Rectangle 11"/>
-          <p:cNvSpPr/>
-          <p:nvPr/>
-        </p:nvSpPr>
-        <p:spPr>
-          <a:xfrm>
-            <a:off x="8066836" y="3337560"/>
-            <a:ext cx="3484778" cy="2377440"/>
-          </a:xfrm>
-          <a:prstGeom prst="roundRect">
-            <a:avLst/>
-          </a:prstGeom>
-          <a:solidFill>
-            <a:srgbClr val="FFFFFF"/>
-          </a:solidFill>
-          <a:ln>
-            <a:noFill/>
-          </a:ln>
-          <a:effectLst/>
-        </p:spPr>
-        <p:style>
-          <a:lnRef idx="1">
-            <a:schemeClr val="accent1"/>
-          </a:lnRef>
-          <a:fillRef idx="3">
-            <a:schemeClr val="accent1"/>
-          </a:fillRef>
-          <a:effectRef idx="2">
-            <a:schemeClr val="accent1"/>
-          </a:effectRef>
-          <a:fontRef idx="minor">
-            <a:schemeClr val="lt1"/>
-          </a:fontRef>
-        </p:style>
-        <p:txBody>
-          <a:bodyPr rtlCol="0" anchor="ctr"/>
-          <a:lstStyle/>
-          <a:p>
-            <a:pPr algn="ctr"/>
-          </a:p>
-        </p:txBody>
-      </p:sp>
-      <p:sp>
-        <p:nvSpPr>
-          <p:cNvPr id="13" name="Rectangle 12"/>
-          <p:cNvSpPr/>
-          <p:nvPr/>
-        </p:nvSpPr>
-        <p:spPr>
-          <a:xfrm>
-            <a:off x="8066836" y="3337560"/>
-            <a:ext cx="3484778" cy="109728"/>
-          </a:xfrm>
-          <a:prstGeom prst="rect">
-            <a:avLst/>
-          </a:prstGeom>
-          <a:solidFill>
-            <a:srgbClr val="E8833A"/>
-          </a:solidFill>
-          <a:ln>
-            <a:noFill/>
-          </a:ln>
-          <a:effectLst/>
-        </p:spPr>
-        <p:style>
-          <a:lnRef idx="1">
-            <a:schemeClr val="accent1"/>
-          </a:lnRef>
-          <a:fillRef idx="3">
-            <a:schemeClr val="accent1"/>
-          </a:fillRef>
-          <a:effectRef idx="2">
-            <a:schemeClr val="accent1"/>
-          </a:effectRef>
-          <a:fontRef idx="minor">
-            <a:schemeClr val="lt1"/>
-          </a:fontRef>
-        </p:style>
-        <p:txBody>
-          <a:bodyPr rtlCol="0" anchor="ctr"/>
-          <a:lstStyle/>
-          <a:p>
-            <a:pPr algn="ctr"/>
-          </a:p>
-        </p:txBody>
-      </p:sp>
-      <p:sp>
-        <p:nvSpPr>
-          <p:cNvPr id="14" name="TextBox 13"/>
-          <p:cNvSpPr txBox="1"/>
-          <p:nvPr/>
-        </p:nvSpPr>
-        <p:spPr>
-          <a:xfrm>
-            <a:off x="8249716" y="3566160"/>
-            <a:ext cx="3119018" cy="2011680"/>
-          </a:xfrm>
-          <a:prstGeom prst="rect">
-            <a:avLst/>
-          </a:prstGeom>
-          <a:noFill/>
-        </p:spPr>
-        <p:txBody>
-          <a:bodyPr wrap="square" anchor="ctr">
-            <a:spAutoFit/>
-          </a:bodyPr>
-          <a:lstStyle/>
-          <a:p>
-            <a:pPr algn="l"/>
-            <a:r>
-              <a:rPr sz="2400" b="0">
-                <a:solidFill>
-                  <a:srgbClr val="222B27"/>
-                </a:solidFill>
-                <a:latin typeface="Calibri"/>
-              </a:rPr>
-              <a:t>Plus tard : IA, autres quartiers</a:t>
-            </a:r>
-          </a:p>
-        </p:txBody>
-      </p:sp>
-      <p:sp>
-        <p:nvSpPr>
-          <p:cNvPr id="15" name="TextBox 14"/>
+              <a:t>cianthiffault2006-png.github.io/hackathon-saint-roch-2026</a:t>
+            </a:r>
+          </a:p>
+        </p:txBody>
+      </p:sp>
+      <p:sp>
+        <p:nvSpPr>
+          <p:cNvPr id="7" name="TextBox 6"/>
           <p:cNvSpPr txBox="1"/>
           <p:nvPr/>
         </p:nvSpPr>
@@ -8001,7 +7596,7 @@
       </p:sp>
       <p:sp>
         <p:nvSpPr>
-          <p:cNvPr id="16" name="TextBox 15"/>
+          <p:cNvPr id="8" name="TextBox 7"/>
           <p:cNvSpPr txBox="1"/>
           <p:nvPr/>
         </p:nvSpPr>
@@ -8030,260 +7625,6 @@
                 <a:latin typeface="Calibri"/>
               </a:rPr>
               <a:t>7</a:t>
-            </a:r>
-          </a:p>
-        </p:txBody>
-      </p:sp>
-    </p:spTree>
-  </p:cSld>
-  <p:clrMapOvr>
-    <a:masterClrMapping/>
-  </p:clrMapOvr>
-</p:sld>
-</file>
-
-<file path=ppt/slides/slide8.xml><?xml version="1.0" encoding="utf-8"?>
-<p:sld xmlns:a="http://schemas.openxmlformats.org/drawingml/2006/main" xmlns:p="http://schemas.openxmlformats.org/presentationml/2006/main" xmlns:r="http://schemas.openxmlformats.org/officeDocument/2006/relationships">
-  <p:cSld>
-    <p:bg>
-      <p:bgPr>
-        <a:solidFill>
-          <a:srgbClr val="FAF7F0"/>
-        </a:solidFill>
-        <a:effectLst/>
-      </p:bgPr>
-    </p:bg>
-    <p:spTree>
-      <p:nvGrpSpPr>
-        <p:cNvPr id="1" name=""/>
-        <p:cNvGrpSpPr/>
-        <p:nvPr/>
-      </p:nvGrpSpPr>
-      <p:grpSpPr/>
-      <p:sp>
-        <p:nvSpPr>
-          <p:cNvPr id="2" name="Rectangle 1"/>
-          <p:cNvSpPr/>
-          <p:nvPr/>
-        </p:nvSpPr>
-        <p:spPr>
-          <a:xfrm>
-            <a:off x="0" y="0"/>
-            <a:ext cx="12191695" cy="1325880"/>
-          </a:xfrm>
-          <a:prstGeom prst="rect">
-            <a:avLst/>
-          </a:prstGeom>
-          <a:solidFill>
-            <a:srgbClr val="1F5F4A"/>
-          </a:solidFill>
-          <a:ln>
-            <a:noFill/>
-          </a:ln>
-          <a:effectLst/>
-        </p:spPr>
-        <p:style>
-          <a:lnRef idx="1">
-            <a:schemeClr val="accent1"/>
-          </a:lnRef>
-          <a:fillRef idx="3">
-            <a:schemeClr val="accent1"/>
-          </a:fillRef>
-          <a:effectRef idx="2">
-            <a:schemeClr val="accent1"/>
-          </a:effectRef>
-          <a:fontRef idx="minor">
-            <a:schemeClr val="lt1"/>
-          </a:fontRef>
-        </p:style>
-        <p:txBody>
-          <a:bodyPr rtlCol="0" anchor="ctr"/>
-          <a:lstStyle/>
-          <a:p>
-            <a:pPr algn="ctr"/>
-          </a:p>
-        </p:txBody>
-      </p:sp>
-      <p:sp>
-        <p:nvSpPr>
-          <p:cNvPr id="3" name="TextBox 2"/>
-          <p:cNvSpPr txBox="1"/>
-          <p:nvPr/>
-        </p:nvSpPr>
-        <p:spPr>
-          <a:xfrm>
-            <a:off x="640080" y="182880"/>
-            <a:ext cx="10911535" cy="960120"/>
-          </a:xfrm>
-          <a:prstGeom prst="rect">
-            <a:avLst/>
-          </a:prstGeom>
-          <a:noFill/>
-        </p:spPr>
-        <p:txBody>
-          <a:bodyPr wrap="square" anchor="ctr">
-            <a:spAutoFit/>
-          </a:bodyPr>
-          <a:lstStyle/>
-          <a:p>
-            <a:pPr algn="l"/>
-            <a:r>
-              <a:rPr sz="4000" b="1">
-                <a:solidFill>
-                  <a:srgbClr val="FFFFFF"/>
-                </a:solidFill>
-                <a:latin typeface="Calibri"/>
-              </a:rPr>
-              <a:t>Conclusion</a:t>
-            </a:r>
-          </a:p>
-        </p:txBody>
-      </p:sp>
-      <p:sp>
-        <p:nvSpPr>
-          <p:cNvPr id="4" name="Rectangle 3"/>
-          <p:cNvSpPr/>
-          <p:nvPr/>
-        </p:nvSpPr>
-        <p:spPr>
-          <a:xfrm>
-            <a:off x="0" y="1325880"/>
-            <a:ext cx="12191695" cy="64008"/>
-          </a:xfrm>
-          <a:prstGeom prst="rect">
-            <a:avLst/>
-          </a:prstGeom>
-          <a:solidFill>
-            <a:srgbClr val="E8833A"/>
-          </a:solidFill>
-          <a:ln>
-            <a:noFill/>
-          </a:ln>
-          <a:effectLst/>
-        </p:spPr>
-        <p:style>
-          <a:lnRef idx="1">
-            <a:schemeClr val="accent1"/>
-          </a:lnRef>
-          <a:fillRef idx="3">
-            <a:schemeClr val="accent1"/>
-          </a:fillRef>
-          <a:effectRef idx="2">
-            <a:schemeClr val="accent1"/>
-          </a:effectRef>
-          <a:fontRef idx="minor">
-            <a:schemeClr val="lt1"/>
-          </a:fontRef>
-        </p:style>
-        <p:txBody>
-          <a:bodyPr rtlCol="0" anchor="ctr"/>
-          <a:lstStyle/>
-          <a:p>
-            <a:pPr algn="ctr"/>
-          </a:p>
-        </p:txBody>
-      </p:sp>
-      <p:sp>
-        <p:nvSpPr>
-          <p:cNvPr id="5" name="TextBox 4"/>
-          <p:cNvSpPr txBox="1"/>
-          <p:nvPr/>
-        </p:nvSpPr>
-        <p:spPr>
-          <a:xfrm>
-            <a:off x="640080" y="1783080"/>
-            <a:ext cx="10911535" cy="1371600"/>
-          </a:xfrm>
-          <a:prstGeom prst="rect">
-            <a:avLst/>
-          </a:prstGeom>
-          <a:noFill/>
-        </p:spPr>
-        <p:txBody>
-          <a:bodyPr wrap="square" anchor="t">
-            <a:spAutoFit/>
-          </a:bodyPr>
-          <a:lstStyle/>
-          <a:p>
-            <a:pPr algn="l"/>
-            <a:r>
-              <a:rPr sz="3400" b="1">
-                <a:solidFill>
-                  <a:srgbClr val="222B27"/>
-                </a:solidFill>
-                <a:latin typeface="Calibri"/>
-              </a:rPr>
-              <a:t>Saint-Roch a déjà tout ce qu’il faut. Maillage aide ses voisins à se trouver.</a:t>
-            </a:r>
-          </a:p>
-        </p:txBody>
-      </p:sp>
-      <p:sp>
-        <p:nvSpPr>
-          <p:cNvPr id="6" name="TextBox 5"/>
-          <p:cNvSpPr txBox="1"/>
-          <p:nvPr/>
-        </p:nvSpPr>
-        <p:spPr>
-          <a:xfrm>
-            <a:off x="640080" y="6400800"/>
-            <a:ext cx="7315200" cy="320040"/>
-          </a:xfrm>
-          <a:prstGeom prst="rect">
-            <a:avLst/>
-          </a:prstGeom>
-          <a:noFill/>
-        </p:spPr>
-        <p:txBody>
-          <a:bodyPr wrap="square" anchor="t">
-            <a:spAutoFit/>
-          </a:bodyPr>
-          <a:lstStyle/>
-          <a:p>
-            <a:pPr algn="l"/>
-            <a:r>
-              <a:rPr sz="1200" b="0">
-                <a:solidFill>
-                  <a:srgbClr val="1F5F4A"/>
-                </a:solidFill>
-                <a:latin typeface="Calibri"/>
-              </a:rPr>
-              <a:t>Équipe 14 · Maillage</a:t>
-            </a:r>
-          </a:p>
-        </p:txBody>
-      </p:sp>
-      <p:sp>
-        <p:nvSpPr>
-          <p:cNvPr id="7" name="TextBox 6"/>
-          <p:cNvSpPr txBox="1"/>
-          <p:nvPr/>
-        </p:nvSpPr>
-        <p:spPr>
-          <a:xfrm>
-            <a:off x="10637215" y="6400800"/>
-            <a:ext cx="914400" cy="320040"/>
-          </a:xfrm>
-          <a:prstGeom prst="rect">
-            <a:avLst/>
-          </a:prstGeom>
-          <a:noFill/>
-        </p:spPr>
-        <p:txBody>
-          <a:bodyPr wrap="square" anchor="t">
-            <a:spAutoFit/>
-          </a:bodyPr>
-          <a:lstStyle/>
-          <a:p>
-            <a:pPr algn="r"/>
-            <a:r>
-              <a:rPr sz="1200" b="0">
-                <a:solidFill>
-                  <a:srgbClr val="1F5F4A"/>
-                </a:solidFill>
-                <a:latin typeface="Calibri"/>
-              </a:rPr>
-              <a:t>8</a:t>
             </a:r>
           </a:p>
         </p:txBody>

</xml_diff>

<commit_message>
Fix verifier defects: invitation date, confirmation wording, French nits, data hygiene
- Invitation shows the real proposed date (dateProposee, same source as the Fiche)
- Honest confirmation text: confirmed when each partner has accepted, Collectif simulated
- Pre-filled profile text: Ville and SDC directories, what the profile shows
- Citoyen instead of Citoyen·ne; script walking time 2 or 3 minutes
- Public repo hygiene: no local path in DEMO-SCRIPT, French TOUR-PLAN header
- Typographic apostrophes, no space before semicolons, testée, texteCafe period
- build_data.py story trio aligned with profils.json; ev-03 typographic apostrophe, ICS regenerated
- Maillage.pptx rebuilt

Co-Authored-By: Claude Opus 5.5 <noreply@anthropic.com>
Claude-Session: https://claude.ai/code/session_01Ee4731zPTWaYnY94BTHWYd
</commit_message>
<xml_diff>
--- a/docs/pitch/Maillage.pptx
+++ b/docs/pitch/Maillage.pptx
@@ -758,7 +758,7 @@
           </a:p>
           <a:p>
             <a:r>
-              <a:t>Signal [CIAN] : dire « Maillage part des répertoires qui existent déjà : les 386 membres du fichier fourni par la SDC, et 614 organismes reconnus à l’échelle de la ville. Personne ne commence avec une page blanche. » Puis la Loi 25 : « les personnes restent cachées; les commerces et organismes apparaissent avec leur nom public seulement, sans coordonnées, étiquetés pré-remplis, jusqu’à activation ». Nos règles s’appuient aussi sur le Plan d’action Saint-Roch. (35 s)</a:t>
+              <a:t>Signal [CIAN] : dire « Maillage part des répertoires qui existent déjà : les 386 membres du fichier fourni par la SDC, et 614 organismes reconnus à l’échelle de la ville. Personne ne commence avec une page blanche. » Puis la Loi 25 : « les personnes restent cachées; les commerces et organismes apparaissent avec leur nom, leur type, une description et une position approximative, sans coordonnées, étiquetés pré-remplis, jusqu’à activation ». Nos règles s’appuient aussi sur le Plan d’action Saint-Roch. (35 s)</a:t>
             </a:r>
           </a:p>
         </p:txBody>
@@ -833,7 +833,7 @@
           </a:p>
           <a:p>
             <a:r>
-              <a:t>Signal [COÉQUIPIÈRE] : verdict d’abord : on l’a testé, on a choisi des règles pour que chaque suggestion s’explique. Chiffres du test seulement si le jury demande. (20 s)</a:t>
+              <a:t>Signal [COÉQUIPIÈRE] : verdict d’abord : on l’a testée, on a choisi des règles pour que chaque suggestion s’explique. Chiffres du test seulement si le jury demande. (20 s)</a:t>
             </a:r>
           </a:p>
         </p:txBody>
@@ -6273,7 +6273,7 @@
                 </a:solidFill>
                 <a:latin typeface="Calibri"/>
               </a:rPr>
-              <a:t>On l’a testé, on a choisi des règles pour que chaque suggestion s’explique.</a:t>
+              <a:t>On l’a testée, on a choisi des règles pour que chaque suggestion s’explique.</a:t>
             </a:r>
           </a:p>
         </p:txBody>

</xml_diff>

<commit_message>
Pitch docs: team lead decisions of 15:55 (consent gate, AI phase 2, accounts, moderation, app store, live thread)
Script: Loi 25 line now says consent is the gate (claim your profile, code to the
address on file, unclaimed visible only to the SDC, demo profiles marked pre-filled);
AI line says typos and some English are tolerated now, all languages in phase 2.
Timing recounted: about 508 words, about 4:48 with clicks.
Q&A: entries 1, 6, 8, 9, 15, 22, 25 rewritten; new 29 (typos/English), 30 (accounts),
31 (app store). Slides 4 and 5 get the consent and phase 2 cards; pptx rebuilt.
README: new "Prototype et vrai deploiement" section.

Co-Authored-By: Claude Opus 5.5 <noreply@anthropic.com>
Claude-Session: https://claude.ai/code/session_01Ee4731zPTWaYnY94BTHWYd
</commit_message>
<xml_diff>
--- a/docs/pitch/Maillage.pptx
+++ b/docs/pitch/Maillage.pptx
@@ -758,7 +758,7 @@
           </a:p>
           <a:p>
             <a:r>
-              <a:t>Signal [CIAN] : dire « Maillage part des répertoires qui existent déjà : les 386 membres du fichier fourni par la SDC, et 614 organismes reconnus à l’échelle de la ville. Personne ne commence avec une page blanche. » Puis la Loi 25 : « les personnes restent cachées; les commerces et organismes apparaissent avec leur nom, leur type, une description et leur emplacement sur la carte, sans coordonnées, étiquetés pré-remplis, jusqu’à activation ». Nos règles s’appuient aussi sur le Plan d’action Saint-Roch. (35 s)</a:t>
+              <a:t>Signal [CIAN] : dire « Maillage part des répertoires qui existent déjà : les 386 membres du fichier fourni par la SDC, et 614 organismes reconnus à l’échelle de la ville. Personne ne commence avec une page blanche. » Puis la Loi 25 : « Pour la Loi 25, le consentement décide. Ces répertoires pré-remplissent les fiches; une fiche devient publique seulement si son responsable la réclame, avec un code envoyé à l’adresse que la SDC ou la Ville a déjà, et consent. Sinon, seule la SDC la voit. La démo montre des fiches fictives, marquées pré-rempli. » Nos règles s’appuient aussi sur le Plan d’action Saint-Roch. (38 s)</a:t>
             </a:r>
           </a:p>
         </p:txBody>
@@ -828,7 +828,7 @@
           <a:lstStyle/>
           <a:p>
             <a:r>
-              <a:t>Visuel : une carte de proposition avec « Pourquoi cette suggestion » et « À confirmer » surlignés; en bas, en petit : « Chaque suggestion s’explique. » Notes du test d’IA (pas sur la diapo, à voix haute seulement si on veut) : « Modèle multilingue dans le navigateur, gratuit, texte sur l’appareil (page /labo/) : 69 s au premier chargement (129 Mo), 13 s ensuite, 0,3 à 0,6 s par phrase. Trouve des profils semblables, pas complémentaires. »</a:t>
+              <a:t>Visuel : une carte de proposition avec « Pourquoi cette suggestion » et « À confirmer » surlignés; en bas, en petit : « Chaque suggestion s’explique. » Notes du test d’IA (pas sur la diapo, à voix haute seulement si on veut) : « Modèle multilingue dans le navigateur, gratuit, texte sur l’appareil (page /labo/) : 69 s au premier chargement (129 Mo), 13 s ensuite, 0,3 à 0,6 s par phrase. Trouve des profils semblables, pas complémentaires. » Ce modèle (paraphrase-multilingual-MiniLM) est multilingue. Déjà dans l’app : tolérance aux fautes, aux accents oubliés et à quelques mots d’anglais. Pas d’IA payante aujourd’hui; en phase 2, celui qui déploie la paie.</a:t>
             </a:r>
           </a:p>
           <a:p>
@@ -5527,7 +5527,7 @@
                 </a:solidFill>
                 <a:latin typeface="Calibri"/>
               </a:rPr>
-              <a:t>React, Vite, TypeScript, MapLibre</a:t>
+              <a:t>React, Vite, TypeScript, MapLibre, GitHub Pages, Claude Code</a:t>
             </a:r>
           </a:p>
         </p:txBody>
@@ -5650,7 +5650,7 @@
                 </a:solidFill>
                 <a:latin typeface="Calibri"/>
               </a:rPr>
-              <a:t>GitHub Pages, Claude Code</a:t>
+              <a:t>386 membres (fichier fourni par la SDC)</a:t>
             </a:r>
           </a:p>
         </p:txBody>
@@ -5773,7 +5773,7 @@
                 </a:solidFill>
                 <a:latin typeface="Calibri"/>
               </a:rPr>
-              <a:t>386 membres (fichier fourni par la SDC)</a:t>
+              <a:t>614 organismes reconnus (toute la ville)</a:t>
             </a:r>
           </a:p>
         </p:txBody>
@@ -5896,7 +5896,7 @@
                 </a:solidFill>
                 <a:latin typeface="Calibri"/>
               </a:rPr>
-              <a:t>614 organismes reconnus (toute la ville)</a:t>
+              <a:t>Données Québec, CC BY 4.0</a:t>
             </a:r>
           </a:p>
         </p:txBody>
@@ -6019,7 +6019,7 @@
                 </a:solidFill>
                 <a:latin typeface="Calibri"/>
               </a:rPr>
-              <a:t>Données Québec, CC BY 4.0</a:t>
+              <a:t>Loi 25 : publique après consentement</a:t>
             </a:r>
           </a:p>
         </p:txBody>
@@ -6642,7 +6642,7 @@
                 </a:solidFill>
                 <a:latin typeface="Calibri"/>
               </a:rPr>
-              <a:t>Phase 2 : l’IA lit la demande libre</a:t>
+              <a:t>IA phase 2 : toutes les langues, toutes les fautes</a:t>
             </a:r>
           </a:p>
         </p:txBody>

</xml_diff>